<commit_message>
fix : ALL PROBLEMS
</commit_message>
<xml_diff>
--- a/Doc/TP5_Auth_Server.pptx
+++ b/Doc/TP5_Auth_Server.pptx
@@ -4,6 +4,9 @@
   <p:sldMasterIdLst>
     <p:sldMasterId id="2147483648" r:id="rId1"/>
   </p:sldMasterIdLst>
+  <p:notesMasterIdLst>
+    <p:notesMasterId r:id="rId11"/>
+  </p:notesMasterIdLst>
   <p:sldIdLst>
     <p:sldId id="256" r:id="rId2"/>
     <p:sldId id="257" r:id="rId3"/>
@@ -15,10 +18,7 @@
     <p:sldId id="263" r:id="rId9"/>
     <p:sldId id="264" r:id="rId10"/>
   </p:sldIdLst>
-  <p:notesMasterIdLst>
-    <p:notesMasterId r:id="rId11"/>
-  </p:notesMasterIdLst>
-  <p:sldSz cx="9144000" cy="5143500"/>
+  <p:sldSz cx="9144000" cy="5143500" type="screen16x9"/>
   <p:notesSz cx="5143500" cy="9144000"/>
   <p:defaultTextStyle>
     <a:lvl1pPr marL="0" algn="l" defTabSz="914400" rtl="0" eaLnBrk="1" latinLnBrk="0" hangingPunct="1">
@@ -112,6 +112,11 @@
       </a:defRPr>
     </a:lvl9pPr>
   </p:defaultTextStyle>
+  <p:extLst>
+    <p:ext uri="{EFAFB233-063F-42B5-8137-9DF3F51BA10A}">
+      <p15:sldGuideLst xmlns:p15="http://schemas.microsoft.com/office/powerpoint/2012/main"/>
+    </p:ext>
+  </p:extLst>
 </p:presentation>
 </file>
 
@@ -137,234 +142,10 @@
           <a:chExt cx="0" cy="0"/>
         </a:xfrm>
       </p:grpSpPr>
-      <p:sp>
-        <p:nvSpPr>
-          <p:cNvPr id="2" name="Header Placeholder 1"/>
-          <p:cNvSpPr>
-            <a:spLocks noGrp="1"/>
-          </p:cNvSpPr>
-          <p:nvPr>
-            <p:ph type="hdr" sz="quarter"/>
-          </p:nvPr>
-        </p:nvSpPr>
-        <p:spPr>
-          <a:xfrm>
-            <a:off x="0" y="0"/>
-            <a:ext cx="2971800" cy="458788"/>
-          </a:xfrm>
-          <a:prstGeom prst="rect">
-            <a:avLst/>
-          </a:prstGeom>
-        </p:spPr>
-        <p:txBody>
-          <a:bodyPr vert="horz" lIns="91440" tIns="45720" rIns="91440" bIns="45720" rtlCol="0"/>
-          <a:lstStyle>
-            <a:lvl1pPr algn="l">
-              <a:defRPr sz="1200"/>
-            </a:lvl1pPr>
-          </a:lstStyle>
-          <a:p>
-            <a:endParaRPr lang="en-US"/>
-          </a:p>
-        </p:txBody>
-      </p:sp>
-      <p:sp>
-        <p:nvSpPr>
-          <p:cNvPr id="3" name="Date Placeholder 2"/>
-          <p:cNvSpPr>
-            <a:spLocks noGrp="1"/>
-          </p:cNvSpPr>
-          <p:nvPr>
-            <p:ph type="dt" idx="1"/>
-          </p:nvPr>
-        </p:nvSpPr>
-        <p:spPr>
-          <a:xfrm>
-            <a:off x="3884613" y="0"/>
-            <a:ext cx="2971800" cy="458788"/>
-          </a:xfrm>
-          <a:prstGeom prst="rect">
-            <a:avLst/>
-          </a:prstGeom>
-        </p:spPr>
-        <p:txBody>
-          <a:bodyPr vert="horz" lIns="91440" tIns="45720" rIns="91440" bIns="45720" rtlCol="0"/>
-          <a:lstStyle>
-            <a:lvl1pPr algn="r">
-              <a:defRPr sz="1200"/>
-            </a:lvl1pPr>
-          </a:lstStyle>
-          <a:p>
-            <a:fld id="{5282F153-3F37-0F45-9E97-73ACFA13230C}" type="datetimeFigureOut">
-              <a:rPr lang="en-US"/>
-              <a:t>7/23/19</a:t>
-            </a:fld>
-            <a:endParaRPr lang="en-US"/>
-          </a:p>
-        </p:txBody>
-      </p:sp>
-      <p:sp>
-        <p:nvSpPr>
-          <p:cNvPr id="4" name="Slide Image Placeholder 3"/>
-          <p:cNvSpPr>
-            <a:spLocks noGrp="1" noRot="1" noChangeAspect="1"/>
-          </p:cNvSpPr>
-          <p:nvPr>
-            <p:ph type="sldImg" idx="2"/>
-          </p:nvPr>
-        </p:nvSpPr>
-        <p:spPr>
-          <a:xfrm>
-            <a:off x="685800" y="1143000"/>
-            <a:ext cx="5486400" cy="3086100"/>
-          </a:xfrm>
-          <a:prstGeom prst="rect">
-            <a:avLst/>
-          </a:prstGeom>
-          <a:noFill/>
-          <a:ln w="12700">
-            <a:solidFill>
-              <a:prstClr val="black"/>
-            </a:solidFill>
-          </a:ln>
-        </p:spPr>
-        <p:txBody>
-          <a:bodyPr vert="horz" lIns="91440" tIns="45720" rIns="91440" bIns="45720" rtlCol="0" anchor="ctr"/>
-          <a:lstStyle/>
-          <a:p>
-            <a:endParaRPr lang="en-US"/>
-          </a:p>
-        </p:txBody>
-      </p:sp>
-      <p:sp>
-        <p:nvSpPr>
-          <p:cNvPr id="5" name="Notes Placeholder 4"/>
-          <p:cNvSpPr>
-            <a:spLocks noGrp="1"/>
-          </p:cNvSpPr>
-          <p:nvPr>
-            <p:ph type="body" sz="quarter" idx="3"/>
-          </p:nvPr>
-        </p:nvSpPr>
-        <p:spPr>
-          <a:xfrm>
-            <a:off x="685800" y="4400550"/>
-            <a:ext cx="5486400" cy="3600450"/>
-          </a:xfrm>
-          <a:prstGeom prst="rect">
-            <a:avLst/>
-          </a:prstGeom>
-        </p:spPr>
-        <p:txBody>
-          <a:bodyPr vert="horz" lIns="91440" tIns="45720" rIns="91440" bIns="45720" rtlCol="0"/>
-          <a:lstStyle/>
-          <a:p>
-            <a:pPr lvl="0"/>
-            <a:r>
-              <a:rPr lang="en-US"/>
-              <a:t>Click to edit Master text styles</a:t>
-            </a:r>
-          </a:p>
-          <a:p>
-            <a:pPr lvl="1"/>
-            <a:r>
-              <a:rPr lang="en-US"/>
-              <a:t>Second level</a:t>
-            </a:r>
-          </a:p>
-          <a:p>
-            <a:pPr lvl="2"/>
-            <a:r>
-              <a:rPr lang="en-US"/>
-              <a:t>Third level</a:t>
-            </a:r>
-          </a:p>
-          <a:p>
-            <a:pPr lvl="3"/>
-            <a:r>
-              <a:rPr lang="en-US"/>
-              <a:t>Fourth level</a:t>
-            </a:r>
-          </a:p>
-          <a:p>
-            <a:pPr lvl="4"/>
-            <a:r>
-              <a:rPr lang="en-US"/>
-              <a:t>Fifth level</a:t>
-            </a:r>
-          </a:p>
-        </p:txBody>
-      </p:sp>
-      <p:sp>
-        <p:nvSpPr>
-          <p:cNvPr id="6" name="Footer Placeholder 5"/>
-          <p:cNvSpPr>
-            <a:spLocks noGrp="1"/>
-          </p:cNvSpPr>
-          <p:nvPr>
-            <p:ph type="ftr" sz="quarter" idx="4"/>
-          </p:nvPr>
-        </p:nvSpPr>
-        <p:spPr>
-          <a:xfrm>
-            <a:off x="0" y="8685213"/>
-            <a:ext cx="2971800" cy="458787"/>
-          </a:xfrm>
-          <a:prstGeom prst="rect">
-            <a:avLst/>
-          </a:prstGeom>
-        </p:spPr>
-        <p:txBody>
-          <a:bodyPr vert="horz" lIns="91440" tIns="45720" rIns="91440" bIns="45720" rtlCol="0" anchor="b"/>
-          <a:lstStyle>
-            <a:lvl1pPr algn="l">
-              <a:defRPr sz="1200"/>
-            </a:lvl1pPr>
-          </a:lstStyle>
-          <a:p>
-            <a:endParaRPr lang="en-US"/>
-          </a:p>
-        </p:txBody>
-      </p:sp>
-      <p:sp>
-        <p:nvSpPr>
-          <p:cNvPr id="7" name="Slide Number Placeholder 6"/>
-          <p:cNvSpPr>
-            <a:spLocks noGrp="1"/>
-          </p:cNvSpPr>
-          <p:nvPr>
-            <p:ph type="sldNum" sz="quarter" idx="5"/>
-          </p:nvPr>
-        </p:nvSpPr>
-        <p:spPr>
-          <a:xfrm>
-            <a:off x="3884613" y="8685213"/>
-            <a:ext cx="2971800" cy="458787"/>
-          </a:xfrm>
-          <a:prstGeom prst="rect">
-            <a:avLst/>
-          </a:prstGeom>
-        </p:spPr>
-        <p:txBody>
-          <a:bodyPr vert="horz" lIns="91440" tIns="45720" rIns="91440" bIns="45720" rtlCol="0" anchor="b"/>
-          <a:lstStyle>
-            <a:lvl1pPr algn="r">
-              <a:defRPr sz="1200"/>
-            </a:lvl1pPr>
-          </a:lstStyle>
-          <a:p>
-            <a:fld id="{CE5E9CC1-C706-0F49-92D6-E571CC5EEA8F}" type="slidenum">
-              <a:rPr lang="en-US"/>
-              <a:t>‹#›</a:t>
-            </a:fld>
-            <a:endParaRPr lang="en-US"/>
-          </a:p>
-        </p:txBody>
-      </p:sp>
     </p:spTree>
     <p:extLst>
       <p:ext uri="{BB962C8B-B14F-4D97-AF65-F5344CB8AC3E}">
-        <p14:creationId xmlns:p14="http://schemas.microsoft.com/office/powerpoint/2010/main" val="1024086991"/>
+        <p14:creationId xmlns:p14="http://schemas.microsoft.com/office/powerpoint/2010/main" val="279749728"/>
       </p:ext>
     </p:extLst>
   </p:cSld>
@@ -508,10 +289,6 @@
           <a:bodyPr/>
           <a:lstStyle/>
           <a:p>
-            <a:r>
-              <a:rPr lang="en-US" dirty="0"/>
-              <a:t/>
-            </a:r>
             <a:endParaRPr lang="en-US" dirty="0"/>
           </a:p>
         </p:txBody>
@@ -596,10 +373,6 @@
           <a:bodyPr/>
           <a:lstStyle/>
           <a:p>
-            <a:r>
-              <a:rPr lang="en-US" dirty="0"/>
-              <a:t/>
-            </a:r>
             <a:endParaRPr lang="en-US" dirty="0"/>
           </a:p>
         </p:txBody>
@@ -684,10 +457,6 @@
           <a:bodyPr/>
           <a:lstStyle/>
           <a:p>
-            <a:r>
-              <a:rPr lang="en-US" dirty="0"/>
-              <a:t/>
-            </a:r>
             <a:endParaRPr lang="en-US" dirty="0"/>
           </a:p>
         </p:txBody>
@@ -772,10 +541,6 @@
           <a:bodyPr/>
           <a:lstStyle/>
           <a:p>
-            <a:r>
-              <a:rPr lang="en-US" dirty="0"/>
-              <a:t/>
-            </a:r>
             <a:endParaRPr lang="en-US" dirty="0"/>
           </a:p>
         </p:txBody>
@@ -860,10 +625,6 @@
           <a:bodyPr/>
           <a:lstStyle/>
           <a:p>
-            <a:r>
-              <a:rPr lang="en-US" dirty="0"/>
-              <a:t/>
-            </a:r>
             <a:endParaRPr lang="en-US" dirty="0"/>
           </a:p>
         </p:txBody>
@@ -948,10 +709,6 @@
           <a:bodyPr/>
           <a:lstStyle/>
           <a:p>
-            <a:r>
-              <a:rPr lang="en-US" dirty="0"/>
-              <a:t/>
-            </a:r>
             <a:endParaRPr lang="en-US" dirty="0"/>
           </a:p>
         </p:txBody>
@@ -1036,10 +793,6 @@
           <a:bodyPr/>
           <a:lstStyle/>
           <a:p>
-            <a:r>
-              <a:rPr lang="en-US" dirty="0"/>
-              <a:t/>
-            </a:r>
             <a:endParaRPr lang="en-US" dirty="0"/>
           </a:p>
         </p:txBody>
@@ -1124,10 +877,6 @@
           <a:bodyPr/>
           <a:lstStyle/>
           <a:p>
-            <a:r>
-              <a:rPr lang="en-US" dirty="0"/>
-              <a:t/>
-            </a:r>
             <a:endParaRPr lang="en-US" dirty="0"/>
           </a:p>
         </p:txBody>
@@ -1212,10 +961,6 @@
           <a:bodyPr/>
           <a:lstStyle/>
           <a:p>
-            <a:r>
-              <a:rPr lang="en-US" dirty="0"/>
-              <a:t/>
-            </a:r>
             <a:endParaRPr lang="en-US" dirty="0"/>
           </a:p>
         </p:txBody>
@@ -1289,6 +1034,11 @@
 <file path=ppt/slideMasters/slideMaster1.xml><?xml version="1.0" encoding="utf-8"?>
 <p:sldMaster xmlns:a="http://schemas.openxmlformats.org/drawingml/2006/main" xmlns:r="http://schemas.openxmlformats.org/officeDocument/2006/relationships" xmlns:p="http://schemas.openxmlformats.org/presentationml/2006/main">
   <p:cSld>
+    <p:bg>
+      <p:bgRef idx="1001">
+        <a:schemeClr val="bg1"/>
+      </p:bgRef>
+    </p:bg>
     <p:spTree>
       <p:nvGrpSpPr>
         <p:cNvPr id="1" name=""/>
@@ -1571,6 +1321,7 @@
         <a:solidFill>
           <a:srgbClr val="1A2B4A"/>
         </a:solidFill>
+        <a:effectLst/>
       </p:bgPr>
     </p:bg>
     <p:spTree>
@@ -1611,6 +1362,13 @@
             <a:prstDash val="solid"/>
           </a:ln>
         </p:spPr>
+        <p:txBody>
+          <a:bodyPr/>
+          <a:lstStyle/>
+          <a:p>
+            <a:endParaRPr lang="fr-FR"/>
+          </a:p>
+        </p:txBody>
       </p:sp>
       <p:sp>
         <p:nvSpPr>
@@ -1636,64 +1394,13 @@
             <a:prstDash val="solid"/>
           </a:ln>
         </p:spPr>
-      </p:sp>
-      <p:sp>
-        <p:nvSpPr>
-          <p:cNvPr id="4" name="Shape 2"/>
-          <p:cNvSpPr/>
-          <p:nvPr/>
-        </p:nvSpPr>
-        <p:spPr>
-          <a:xfrm>
-            <a:off x="6583680" y="-1097280"/>
-            <a:ext cx="3200400" cy="3200400"/>
-          </a:xfrm>
-          <a:prstGeom prst="ellipse">
-            <a:avLst/>
-          </a:prstGeom>
-          <a:solidFill>
-            <a:srgbClr val="0D9488">
-              <a:alpha val="18000"/>
-            </a:srgbClr>
-          </a:solidFill>
-          <a:ln w="12700">
-            <a:solidFill>
-              <a:srgbClr val="0D9488">
-                <a:alpha val="18000"/>
-              </a:srgbClr>
-            </a:solidFill>
-            <a:prstDash val="solid"/>
-          </a:ln>
-        </p:spPr>
-      </p:sp>
-      <p:sp>
-        <p:nvSpPr>
-          <p:cNvPr id="5" name="Shape 3"/>
-          <p:cNvSpPr/>
-          <p:nvPr/>
-        </p:nvSpPr>
-        <p:spPr>
-          <a:xfrm>
-            <a:off x="7132320" y="-457200"/>
-            <a:ext cx="2011680" cy="2011680"/>
-          </a:xfrm>
-          <a:prstGeom prst="ellipse">
-            <a:avLst/>
-          </a:prstGeom>
-          <a:solidFill>
-            <a:srgbClr val="14B8A6">
-              <a:alpha val="30000"/>
-            </a:srgbClr>
-          </a:solidFill>
-          <a:ln w="12700">
-            <a:solidFill>
-              <a:srgbClr val="14B8A6">
-                <a:alpha val="30000"/>
-              </a:srgbClr>
-            </a:solidFill>
-            <a:prstDash val="solid"/>
-          </a:ln>
-        </p:spPr>
+        <p:txBody>
+          <a:bodyPr/>
+          <a:lstStyle/>
+          <a:p>
+            <a:endParaRPr lang="fr-FR"/>
+          </a:p>
+        </p:txBody>
       </p:sp>
       <p:sp>
         <p:nvSpPr>
@@ -1707,9 +1414,7 @@
             <a:ext cx="1188720" cy="384048"/>
           </a:xfrm>
           <a:prstGeom prst="rect">
-            <a:avLst>
-              <a:gd name="adj" fmla="val 11905"/>
-            </a:avLst>
+            <a:avLst/>
           </a:prstGeom>
           <a:solidFill>
             <a:srgbClr val="0D9488"/>
@@ -1721,6 +1426,13 @@
             <a:prstDash val="solid"/>
           </a:ln>
         </p:spPr>
+        <p:txBody>
+          <a:bodyPr/>
+          <a:lstStyle/>
+          <a:p>
+            <a:endParaRPr lang="fr-FR"/>
+          </a:p>
+        </p:txBody>
       </p:sp>
       <p:sp>
         <p:nvSpPr>
@@ -1743,7 +1455,7 @@
           <a:bodyPr wrap="square" lIns="0" tIns="0" rIns="0" bIns="0" rtlCol="0" anchor="ctr"/>
           <a:lstStyle/>
           <a:p>
-            <a:pPr algn="ctr" indent="0" marL="0">
+            <a:pPr marL="0" indent="0" algn="ctr">
               <a:buNone/>
             </a:pPr>
             <a:r>
@@ -1779,7 +1491,7 @@
           <a:bodyPr wrap="square" rtlCol="0" anchor="ctr"/>
           <a:lstStyle/>
           <a:p>
-            <a:pPr indent="0" marL="0">
+            <a:pPr marL="0" indent="0">
               <a:buNone/>
             </a:pPr>
             <a:r>
@@ -1818,7 +1530,7 @@
           <a:bodyPr wrap="square" rtlCol="0" anchor="ctr"/>
           <a:lstStyle/>
           <a:p>
-            <a:pPr indent="0" marL="0">
+            <a:pPr marL="0" indent="0">
               <a:buNone/>
             </a:pPr>
             <a:r>
@@ -1864,6 +1576,13 @@
             <a:prstDash val="solid"/>
           </a:ln>
         </p:spPr>
+        <p:txBody>
+          <a:bodyPr/>
+          <a:lstStyle/>
+          <a:p>
+            <a:endParaRPr lang="fr-FR"/>
+          </a:p>
+        </p:txBody>
       </p:sp>
       <p:sp>
         <p:nvSpPr>
@@ -1886,7 +1605,7 @@
           <a:bodyPr wrap="square" rtlCol="0" anchor="ctr"/>
           <a:lstStyle/>
           <a:p>
-            <a:pPr indent="0" marL="0">
+            <a:pPr marL="0" indent="0">
               <a:buNone/>
             </a:pPr>
             <a:r>
@@ -1901,67 +1620,6 @@
               <a:t>Démarche &amp; Réalisations attendues  ·  Spring Boot  ·  Docker  ·  GitHub Actions</a:t>
             </a:r>
             <a:endParaRPr lang="en-US" sz="1300" dirty="0"/>
-          </a:p>
-        </p:txBody>
-      </p:sp>
-      <p:sp>
-        <p:nvSpPr>
-          <p:cNvPr id="12" name="Shape 10"/>
-          <p:cNvSpPr/>
-          <p:nvPr/>
-        </p:nvSpPr>
-        <p:spPr>
-          <a:xfrm>
-            <a:off x="0" y="4800600"/>
-            <a:ext cx="9144000" cy="342900"/>
-          </a:xfrm>
-          <a:prstGeom prst="rect">
-            <a:avLst/>
-          </a:prstGeom>
-          <a:solidFill>
-            <a:srgbClr val="1E293B"/>
-          </a:solidFill>
-          <a:ln w="12700">
-            <a:solidFill>
-              <a:srgbClr val="1E293B"/>
-            </a:solidFill>
-            <a:prstDash val="solid"/>
-          </a:ln>
-        </p:spPr>
-      </p:sp>
-      <p:sp>
-        <p:nvSpPr>
-          <p:cNvPr id="13" name="Text 11"/>
-          <p:cNvSpPr/>
-          <p:nvPr/>
-        </p:nvSpPr>
-        <p:spPr>
-          <a:xfrm>
-            <a:off x="365760" y="4800600"/>
-            <a:ext cx="8412480" cy="342900"/>
-          </a:xfrm>
-          <a:prstGeom prst="rect">
-            <a:avLst/>
-          </a:prstGeom>
-          <a:noFill/>
-          <a:ln/>
-        </p:spPr>
-        <p:txBody>
-          <a:bodyPr wrap="square" rtlCol="0" anchor="ctr"/>
-          <a:lstStyle/>
-          <a:p>
-            <a:pPr indent="0" marL="0">
-              <a:buNone/>
-            </a:pPr>
-            <a:r>
-              <a:rPr lang="en-US" sz="1000" dirty="0">
-                <a:solidFill>
-                  <a:srgbClr val="94A3B8"/>
-                </a:solidFill>
-              </a:rPr>
-              <a:t>D. Samfat  ·  Serveur d'Authentification  ·  2024-2025</a:t>
-            </a:r>
-            <a:endParaRPr lang="en-US" sz="1000" dirty="0"/>
           </a:p>
         </p:txBody>
       </p:sp>
@@ -1981,6 +1639,7 @@
         <a:solidFill>
           <a:srgbClr val="F4F7F9"/>
         </a:solidFill>
+        <a:effectLst/>
       </p:bgPr>
     </p:bg>
     <p:spTree>
@@ -2021,6 +1680,13 @@
             <a:prstDash val="solid"/>
           </a:ln>
         </p:spPr>
+        <p:txBody>
+          <a:bodyPr/>
+          <a:lstStyle/>
+          <a:p>
+            <a:endParaRPr lang="fr-FR"/>
+          </a:p>
+        </p:txBody>
       </p:sp>
       <p:sp>
         <p:nvSpPr>
@@ -2046,6 +1712,13 @@
             <a:prstDash val="solid"/>
           </a:ln>
         </p:spPr>
+        <p:txBody>
+          <a:bodyPr/>
+          <a:lstStyle/>
+          <a:p>
+            <a:endParaRPr lang="fr-FR"/>
+          </a:p>
+        </p:txBody>
       </p:sp>
       <p:sp>
         <p:nvSpPr>
@@ -2068,7 +1741,7 @@
           <a:bodyPr wrap="square" rtlCol="0" anchor="ctr"/>
           <a:lstStyle/>
           <a:p>
-            <a:pPr indent="0" marL="0">
+            <a:pPr marL="0" indent="0">
               <a:buNone/>
             </a:pPr>
             <a:r>
@@ -2104,7 +1777,7 @@
           <a:bodyPr wrap="square" rtlCol="0" anchor="ctr"/>
           <a:lstStyle/>
           <a:p>
-            <a:pPr algn="r" indent="0" marL="0">
+            <a:pPr marL="0" indent="0" algn="r">
               <a:buNone/>
             </a:pPr>
             <a:r>
@@ -2143,13 +1816,20 @@
             <a:prstDash val="solid"/>
           </a:ln>
           <a:effectLst>
-            <a:outerShdw sx="100000" sy="100000" kx="0" ky="0" algn="bl" rotWithShape="0" blurRad="101600" dist="38100" dir="8100000">
+            <a:outerShdw blurRad="101600" dist="38100" dir="8100000" algn="bl" rotWithShape="0">
               <a:srgbClr val="000000">
                 <a:alpha val="12000"/>
               </a:srgbClr>
             </a:outerShdw>
           </a:effectLst>
         </p:spPr>
+        <p:txBody>
+          <a:bodyPr/>
+          <a:lstStyle/>
+          <a:p>
+            <a:endParaRPr lang="fr-FR"/>
+          </a:p>
+        </p:txBody>
       </p:sp>
       <p:sp>
         <p:nvSpPr>
@@ -2175,6 +1855,13 @@
             <a:prstDash val="solid"/>
           </a:ln>
         </p:spPr>
+        <p:txBody>
+          <a:bodyPr/>
+          <a:lstStyle/>
+          <a:p>
+            <a:endParaRPr lang="fr-FR"/>
+          </a:p>
+        </p:txBody>
       </p:sp>
       <p:sp>
         <p:nvSpPr>
@@ -2197,7 +1884,7 @@
           <a:bodyPr wrap="square" lIns="0" tIns="0" rIns="0" bIns="0" rtlCol="0" anchor="ctr"/>
           <a:lstStyle/>
           <a:p>
-            <a:pPr indent="0" marL="0">
+            <a:pPr marL="0" indent="0">
               <a:buNone/>
             </a:pPr>
             <a:r>
@@ -2348,13 +2035,20 @@
             <a:prstDash val="solid"/>
           </a:ln>
           <a:effectLst>
-            <a:outerShdw sx="100000" sy="100000" kx="0" ky="0" algn="bl" rotWithShape="0" blurRad="101600" dist="38100" dir="8100000">
+            <a:outerShdw blurRad="101600" dist="38100" dir="8100000" algn="bl" rotWithShape="0">
               <a:srgbClr val="000000">
                 <a:alpha val="12000"/>
               </a:srgbClr>
             </a:outerShdw>
           </a:effectLst>
         </p:spPr>
+        <p:txBody>
+          <a:bodyPr/>
+          <a:lstStyle/>
+          <a:p>
+            <a:endParaRPr lang="fr-FR"/>
+          </a:p>
+        </p:txBody>
       </p:sp>
       <p:sp>
         <p:nvSpPr>
@@ -2380,6 +2074,13 @@
             <a:prstDash val="solid"/>
           </a:ln>
         </p:spPr>
+        <p:txBody>
+          <a:bodyPr/>
+          <a:lstStyle/>
+          <a:p>
+            <a:endParaRPr lang="fr-FR"/>
+          </a:p>
+        </p:txBody>
       </p:sp>
       <p:sp>
         <p:nvSpPr>
@@ -2402,7 +2103,7 @@
           <a:bodyPr wrap="square" lIns="0" tIns="0" rIns="0" bIns="0" rtlCol="0" anchor="ctr"/>
           <a:lstStyle/>
           <a:p>
-            <a:pPr indent="0" marL="0">
+            <a:pPr marL="0" indent="0">
               <a:buNone/>
             </a:pPr>
             <a:r>
@@ -2508,67 +2209,6 @@
               <a:t>Automatiser le build Docker avec GitHub Actions</a:t>
             </a:r>
             <a:endParaRPr lang="en-US" sz="1200" dirty="0"/>
-          </a:p>
-        </p:txBody>
-      </p:sp>
-      <p:sp>
-        <p:nvSpPr>
-          <p:cNvPr id="14" name="Shape 12"/>
-          <p:cNvSpPr/>
-          <p:nvPr/>
-        </p:nvSpPr>
-        <p:spPr>
-          <a:xfrm>
-            <a:off x="0" y="4800600"/>
-            <a:ext cx="9144000" cy="342900"/>
-          </a:xfrm>
-          <a:prstGeom prst="rect">
-            <a:avLst/>
-          </a:prstGeom>
-          <a:solidFill>
-            <a:srgbClr val="1A2B4A"/>
-          </a:solidFill>
-          <a:ln w="12700">
-            <a:solidFill>
-              <a:srgbClr val="1A2B4A"/>
-            </a:solidFill>
-            <a:prstDash val="solid"/>
-          </a:ln>
-        </p:spPr>
-      </p:sp>
-      <p:sp>
-        <p:nvSpPr>
-          <p:cNvPr id="15" name="Text 13"/>
-          <p:cNvSpPr/>
-          <p:nvPr/>
-        </p:nvSpPr>
-        <p:spPr>
-          <a:xfrm>
-            <a:off x="365760" y="4800600"/>
-            <a:ext cx="8412480" cy="342900"/>
-          </a:xfrm>
-          <a:prstGeom prst="rect">
-            <a:avLst/>
-          </a:prstGeom>
-          <a:noFill/>
-          <a:ln/>
-        </p:spPr>
-        <p:txBody>
-          <a:bodyPr wrap="square" rtlCol="0" anchor="ctr"/>
-          <a:lstStyle/>
-          <a:p>
-            <a:pPr indent="0" marL="0">
-              <a:buNone/>
-            </a:pPr>
-            <a:r>
-              <a:rPr lang="en-US" sz="1000" dirty="0">
-                <a:solidFill>
-                  <a:srgbClr val="94A3B8"/>
-                </a:solidFill>
-              </a:rPr>
-              <a:t>TP5 – Password Change &amp; Docker  ·  D. Samfat</a:t>
-            </a:r>
-            <a:endParaRPr lang="en-US" sz="1000" dirty="0"/>
           </a:p>
         </p:txBody>
       </p:sp>
@@ -2588,6 +2228,7 @@
         <a:solidFill>
           <a:srgbClr val="F4F7F9"/>
         </a:solidFill>
+        <a:effectLst/>
       </p:bgPr>
     </p:bg>
     <p:spTree>
@@ -2628,6 +2269,13 @@
             <a:prstDash val="solid"/>
           </a:ln>
         </p:spPr>
+        <p:txBody>
+          <a:bodyPr/>
+          <a:lstStyle/>
+          <a:p>
+            <a:endParaRPr lang="fr-FR"/>
+          </a:p>
+        </p:txBody>
       </p:sp>
       <p:sp>
         <p:nvSpPr>
@@ -2653,6 +2301,13 @@
             <a:prstDash val="solid"/>
           </a:ln>
         </p:spPr>
+        <p:txBody>
+          <a:bodyPr/>
+          <a:lstStyle/>
+          <a:p>
+            <a:endParaRPr lang="fr-FR"/>
+          </a:p>
+        </p:txBody>
       </p:sp>
       <p:sp>
         <p:nvSpPr>
@@ -2675,7 +2330,7 @@
           <a:bodyPr wrap="square" rtlCol="0" anchor="ctr"/>
           <a:lstStyle/>
           <a:p>
-            <a:pPr indent="0" marL="0">
+            <a:pPr marL="0" indent="0">
               <a:buNone/>
             </a:pPr>
             <a:r>
@@ -2711,7 +2366,7 @@
           <a:bodyPr wrap="square" rtlCol="0" anchor="ctr"/>
           <a:lstStyle/>
           <a:p>
-            <a:pPr algn="r" indent="0" marL="0">
+            <a:pPr marL="0" indent="0" algn="r">
               <a:buNone/>
             </a:pPr>
             <a:r>
@@ -2750,6 +2405,13 @@
             <a:prstDash val="solid"/>
           </a:ln>
         </p:spPr>
+        <p:txBody>
+          <a:bodyPr/>
+          <a:lstStyle/>
+          <a:p>
+            <a:endParaRPr lang="fr-FR"/>
+          </a:p>
+        </p:txBody>
       </p:sp>
       <p:sp>
         <p:nvSpPr>
@@ -2772,7 +2434,7 @@
           <a:bodyPr wrap="square" rtlCol="0" anchor="ctr"/>
           <a:lstStyle/>
           <a:p>
-            <a:pPr algn="ctr" indent="0" marL="0">
+            <a:pPr marL="0" indent="0" algn="ctr">
               <a:buNone/>
             </a:pPr>
             <a:r>
@@ -2814,13 +2476,20 @@
             <a:prstDash val="solid"/>
           </a:ln>
           <a:effectLst>
-            <a:outerShdw sx="100000" sy="100000" kx="0" ky="0" algn="bl" rotWithShape="0" blurRad="101600" dist="38100" dir="8100000">
+            <a:outerShdw blurRad="101600" dist="38100" dir="8100000" algn="bl" rotWithShape="0">
               <a:srgbClr val="000000">
                 <a:alpha val="12000"/>
               </a:srgbClr>
             </a:outerShdw>
           </a:effectLst>
         </p:spPr>
+        <p:txBody>
+          <a:bodyPr/>
+          <a:lstStyle/>
+          <a:p>
+            <a:endParaRPr lang="fr-FR"/>
+          </a:p>
+        </p:txBody>
       </p:sp>
       <p:sp>
         <p:nvSpPr>
@@ -2843,7 +2512,7 @@
           <a:bodyPr wrap="square" rtlCol="0" anchor="ctr"/>
           <a:lstStyle/>
           <a:p>
-            <a:pPr indent="0" marL="0">
+            <a:pPr marL="0" indent="0">
               <a:buNone/>
             </a:pPr>
             <a:r>
@@ -2860,7 +2529,7 @@
             <a:endParaRPr lang="en-US" sz="1050" dirty="0"/>
           </a:p>
           <a:p>
-            <a:pPr indent="0" marL="0">
+            <a:pPr marL="0" indent="0">
               <a:buNone/>
             </a:pPr>
             <a:r>
@@ -2877,7 +2546,7 @@
             <a:endParaRPr lang="en-US" sz="1050" dirty="0"/>
           </a:p>
           <a:p>
-            <a:pPr indent="0" marL="0">
+            <a:pPr marL="0" indent="0">
               <a:buNone/>
             </a:pPr>
             <a:r>
@@ -2894,7 +2563,7 @@
             <a:endParaRPr lang="en-US" sz="1050" dirty="0"/>
           </a:p>
           <a:p>
-            <a:pPr indent="0" marL="0">
+            <a:pPr marL="0" indent="0">
               <a:buNone/>
             </a:pPr>
             <a:r>
@@ -2911,7 +2580,7 @@
             <a:endParaRPr lang="en-US" sz="1050" dirty="0"/>
           </a:p>
           <a:p>
-            <a:pPr indent="0" marL="0">
+            <a:pPr marL="0" indent="0">
               <a:buNone/>
             </a:pPr>
             <a:r>
@@ -2928,7 +2597,7 @@
             <a:endParaRPr lang="en-US" sz="1050" dirty="0"/>
           </a:p>
           <a:p>
-            <a:pPr indent="0" marL="0">
+            <a:pPr marL="0" indent="0">
               <a:buNone/>
             </a:pPr>
             <a:r>
@@ -2970,13 +2639,20 @@
             <a:prstDash val="solid"/>
           </a:ln>
           <a:effectLst>
-            <a:outerShdw sx="100000" sy="100000" kx="0" ky="0" algn="bl" rotWithShape="0" blurRad="101600" dist="38100" dir="8100000">
+            <a:outerShdw blurRad="101600" dist="38100" dir="8100000" algn="bl" rotWithShape="0">
               <a:srgbClr val="000000">
                 <a:alpha val="12000"/>
               </a:srgbClr>
             </a:outerShdw>
           </a:effectLst>
         </p:spPr>
+        <p:txBody>
+          <a:bodyPr/>
+          <a:lstStyle/>
+          <a:p>
+            <a:endParaRPr lang="fr-FR"/>
+          </a:p>
+        </p:txBody>
       </p:sp>
       <p:sp>
         <p:nvSpPr>
@@ -3002,6 +2678,13 @@
             <a:prstDash val="solid"/>
           </a:ln>
         </p:spPr>
+        <p:txBody>
+          <a:bodyPr/>
+          <a:lstStyle/>
+          <a:p>
+            <a:endParaRPr lang="fr-FR"/>
+          </a:p>
+        </p:txBody>
       </p:sp>
       <p:sp>
         <p:nvSpPr>
@@ -3024,7 +2707,7 @@
           <a:bodyPr wrap="square" lIns="0" tIns="0" rIns="0" bIns="0" rtlCol="0" anchor="ctr"/>
           <a:lstStyle/>
           <a:p>
-            <a:pPr indent="0" marL="0">
+            <a:pPr marL="0" indent="0">
               <a:buNone/>
             </a:pPr>
             <a:r>
@@ -3063,6 +2746,13 @@
             <a:prstDash val="solid"/>
           </a:ln>
         </p:spPr>
+        <p:txBody>
+          <a:bodyPr/>
+          <a:lstStyle/>
+          <a:p>
+            <a:endParaRPr lang="fr-FR"/>
+          </a:p>
+        </p:txBody>
       </p:sp>
       <p:sp>
         <p:nvSpPr>
@@ -3085,7 +2775,7 @@
           <a:bodyPr wrap="square" lIns="0" tIns="0" rIns="0" bIns="0" rtlCol="0" anchor="ctr"/>
           <a:lstStyle/>
           <a:p>
-            <a:pPr algn="ctr" indent="0" marL="0">
+            <a:pPr marL="0" indent="0" algn="ctr">
               <a:buNone/>
             </a:pPr>
             <a:r>
@@ -3121,7 +2811,7 @@
           <a:bodyPr wrap="square" rtlCol="0" anchor="ctr"/>
           <a:lstStyle/>
           <a:p>
-            <a:pPr indent="0" marL="0">
+            <a:pPr marL="0" indent="0">
               <a:buNone/>
             </a:pPr>
             <a:r>
@@ -3160,6 +2850,13 @@
             <a:prstDash val="solid"/>
           </a:ln>
         </p:spPr>
+        <p:txBody>
+          <a:bodyPr/>
+          <a:lstStyle/>
+          <a:p>
+            <a:endParaRPr lang="fr-FR"/>
+          </a:p>
+        </p:txBody>
       </p:sp>
       <p:sp>
         <p:nvSpPr>
@@ -3182,7 +2879,7 @@
           <a:bodyPr wrap="square" lIns="0" tIns="0" rIns="0" bIns="0" rtlCol="0" anchor="ctr"/>
           <a:lstStyle/>
           <a:p>
-            <a:pPr algn="ctr" indent="0" marL="0">
+            <a:pPr marL="0" indent="0" algn="ctr">
               <a:buNone/>
             </a:pPr>
             <a:r>
@@ -3218,7 +2915,7 @@
           <a:bodyPr wrap="square" rtlCol="0" anchor="ctr"/>
           <a:lstStyle/>
           <a:p>
-            <a:pPr indent="0" marL="0">
+            <a:pPr marL="0" indent="0">
               <a:buNone/>
             </a:pPr>
             <a:r>
@@ -3257,6 +2954,13 @@
             <a:prstDash val="solid"/>
           </a:ln>
         </p:spPr>
+        <p:txBody>
+          <a:bodyPr/>
+          <a:lstStyle/>
+          <a:p>
+            <a:endParaRPr lang="fr-FR"/>
+          </a:p>
+        </p:txBody>
       </p:sp>
       <p:sp>
         <p:nvSpPr>
@@ -3279,7 +2983,7 @@
           <a:bodyPr wrap="square" lIns="0" tIns="0" rIns="0" bIns="0" rtlCol="0" anchor="ctr"/>
           <a:lstStyle/>
           <a:p>
-            <a:pPr algn="ctr" indent="0" marL="0">
+            <a:pPr marL="0" indent="0" algn="ctr">
               <a:buNone/>
             </a:pPr>
             <a:r>
@@ -3315,7 +3019,7 @@
           <a:bodyPr wrap="square" rtlCol="0" anchor="ctr"/>
           <a:lstStyle/>
           <a:p>
-            <a:pPr indent="0" marL="0">
+            <a:pPr marL="0" indent="0">
               <a:buNone/>
             </a:pPr>
             <a:r>
@@ -3354,6 +3058,13 @@
             <a:prstDash val="solid"/>
           </a:ln>
         </p:spPr>
+        <p:txBody>
+          <a:bodyPr/>
+          <a:lstStyle/>
+          <a:p>
+            <a:endParaRPr lang="fr-FR"/>
+          </a:p>
+        </p:txBody>
       </p:sp>
       <p:sp>
         <p:nvSpPr>
@@ -3376,7 +3087,7 @@
           <a:bodyPr wrap="square" lIns="0" tIns="0" rIns="0" bIns="0" rtlCol="0" anchor="ctr"/>
           <a:lstStyle/>
           <a:p>
-            <a:pPr algn="ctr" indent="0" marL="0">
+            <a:pPr marL="0" indent="0" algn="ctr">
               <a:buNone/>
             </a:pPr>
             <a:r>
@@ -3412,7 +3123,7 @@
           <a:bodyPr wrap="square" rtlCol="0" anchor="ctr"/>
           <a:lstStyle/>
           <a:p>
-            <a:pPr indent="0" marL="0">
+            <a:pPr marL="0" indent="0">
               <a:buNone/>
             </a:pPr>
             <a:r>
@@ -3451,6 +3162,13 @@
             <a:prstDash val="solid"/>
           </a:ln>
         </p:spPr>
+        <p:txBody>
+          <a:bodyPr/>
+          <a:lstStyle/>
+          <a:p>
+            <a:endParaRPr lang="fr-FR"/>
+          </a:p>
+        </p:txBody>
       </p:sp>
       <p:sp>
         <p:nvSpPr>
@@ -3473,7 +3191,7 @@
           <a:bodyPr wrap="square" lIns="0" tIns="0" rIns="0" bIns="0" rtlCol="0" anchor="ctr"/>
           <a:lstStyle/>
           <a:p>
-            <a:pPr algn="ctr" indent="0" marL="0">
+            <a:pPr marL="0" indent="0" algn="ctr">
               <a:buNone/>
             </a:pPr>
             <a:r>
@@ -3509,7 +3227,7 @@
           <a:bodyPr wrap="square" rtlCol="0" anchor="ctr"/>
           <a:lstStyle/>
           <a:p>
-            <a:pPr indent="0" marL="0">
+            <a:pPr marL="0" indent="0">
               <a:buNone/>
             </a:pPr>
             <a:r>
@@ -3548,6 +3266,13 @@
             <a:prstDash val="solid"/>
           </a:ln>
         </p:spPr>
+        <p:txBody>
+          <a:bodyPr/>
+          <a:lstStyle/>
+          <a:p>
+            <a:endParaRPr lang="fr-FR"/>
+          </a:p>
+        </p:txBody>
       </p:sp>
       <p:sp>
         <p:nvSpPr>
@@ -3570,7 +3295,7 @@
           <a:bodyPr wrap="square" lIns="0" tIns="0" rIns="0" bIns="0" rtlCol="0" anchor="ctr"/>
           <a:lstStyle/>
           <a:p>
-            <a:pPr algn="ctr" indent="0" marL="0">
+            <a:pPr marL="0" indent="0" algn="ctr">
               <a:buNone/>
             </a:pPr>
             <a:r>
@@ -3606,7 +3331,7 @@
           <a:bodyPr wrap="square" rtlCol="0" anchor="ctr"/>
           <a:lstStyle/>
           <a:p>
-            <a:pPr indent="0" marL="0">
+            <a:pPr marL="0" indent="0">
               <a:buNone/>
             </a:pPr>
             <a:r>
@@ -3645,6 +3370,13 @@
             <a:prstDash val="solid"/>
           </a:ln>
         </p:spPr>
+        <p:txBody>
+          <a:bodyPr/>
+          <a:lstStyle/>
+          <a:p>
+            <a:endParaRPr lang="fr-FR"/>
+          </a:p>
+        </p:txBody>
       </p:sp>
       <p:sp>
         <p:nvSpPr>
@@ -3667,7 +3399,7 @@
           <a:bodyPr wrap="square" lIns="0" tIns="0" rIns="0" bIns="0" rtlCol="0" anchor="ctr"/>
           <a:lstStyle/>
           <a:p>
-            <a:pPr algn="ctr" indent="0" marL="0">
+            <a:pPr marL="0" indent="0" algn="ctr">
               <a:buNone/>
             </a:pPr>
             <a:r>
@@ -3703,7 +3435,7 @@
           <a:bodyPr wrap="square" rtlCol="0" anchor="ctr"/>
           <a:lstStyle/>
           <a:p>
-            <a:pPr indent="0" marL="0">
+            <a:pPr marL="0" indent="0">
               <a:buNone/>
             </a:pPr>
             <a:r>
@@ -3726,7 +3458,7 @@
         </p:nvSpPr>
         <p:spPr>
           <a:xfrm>
-            <a:off x="320040" y="3840480"/>
+            <a:off x="457200" y="3737490"/>
             <a:ext cx="4023360" cy="411480"/>
           </a:xfrm>
           <a:prstGeom prst="rect">
@@ -3739,7 +3471,7 @@
           <a:bodyPr wrap="square" rtlCol="0" anchor="ctr"/>
           <a:lstStyle/>
           <a:p>
-            <a:pPr indent="0" marL="0">
+            <a:pPr marL="0" indent="0">
               <a:buNone/>
             </a:pPr>
             <a:r>
@@ -3749,67 +3481,6 @@
                 </a:solidFill>
               </a:rPr>
               <a:t>L'utilisateur doit être authentifié pour accéder à cet endpoint</a:t>
-            </a:r>
-            <a:endParaRPr lang="en-US" sz="1000" dirty="0"/>
-          </a:p>
-        </p:txBody>
-      </p:sp>
-      <p:sp>
-        <p:nvSpPr>
-          <p:cNvPr id="35" name="Shape 33"/>
-          <p:cNvSpPr/>
-          <p:nvPr/>
-        </p:nvSpPr>
-        <p:spPr>
-          <a:xfrm>
-            <a:off x="0" y="4800600"/>
-            <a:ext cx="9144000" cy="342900"/>
-          </a:xfrm>
-          <a:prstGeom prst="rect">
-            <a:avLst/>
-          </a:prstGeom>
-          <a:solidFill>
-            <a:srgbClr val="1A2B4A"/>
-          </a:solidFill>
-          <a:ln w="12700">
-            <a:solidFill>
-              <a:srgbClr val="1A2B4A"/>
-            </a:solidFill>
-            <a:prstDash val="solid"/>
-          </a:ln>
-        </p:spPr>
-      </p:sp>
-      <p:sp>
-        <p:nvSpPr>
-          <p:cNvPr id="36" name="Text 34"/>
-          <p:cNvSpPr/>
-          <p:nvPr/>
-        </p:nvSpPr>
-        <p:spPr>
-          <a:xfrm>
-            <a:off x="365760" y="4800600"/>
-            <a:ext cx="8412480" cy="342900"/>
-          </a:xfrm>
-          <a:prstGeom prst="rect">
-            <a:avLst/>
-          </a:prstGeom>
-          <a:noFill/>
-          <a:ln/>
-        </p:spPr>
-        <p:txBody>
-          <a:bodyPr wrap="square" rtlCol="0" anchor="ctr"/>
-          <a:lstStyle/>
-          <a:p>
-            <a:pPr indent="0" marL="0">
-              <a:buNone/>
-            </a:pPr>
-            <a:r>
-              <a:rPr lang="en-US" sz="1000" dirty="0">
-                <a:solidFill>
-                  <a:srgbClr val="94A3B8"/>
-                </a:solidFill>
-              </a:rPr>
-              <a:t>TP5 – Password Change &amp; Docker  ·  D. Samfat</a:t>
             </a:r>
             <a:endParaRPr lang="en-US" sz="1000" dirty="0"/>
           </a:p>
@@ -3831,6 +3502,7 @@
         <a:solidFill>
           <a:srgbClr val="F4F7F9"/>
         </a:solidFill>
+        <a:effectLst/>
       </p:bgPr>
     </p:bg>
     <p:spTree>
@@ -3871,6 +3543,13 @@
             <a:prstDash val="solid"/>
           </a:ln>
         </p:spPr>
+        <p:txBody>
+          <a:bodyPr/>
+          <a:lstStyle/>
+          <a:p>
+            <a:endParaRPr lang="fr-FR"/>
+          </a:p>
+        </p:txBody>
       </p:sp>
       <p:sp>
         <p:nvSpPr>
@@ -3896,6 +3575,13 @@
             <a:prstDash val="solid"/>
           </a:ln>
         </p:spPr>
+        <p:txBody>
+          <a:bodyPr/>
+          <a:lstStyle/>
+          <a:p>
+            <a:endParaRPr lang="fr-FR"/>
+          </a:p>
+        </p:txBody>
       </p:sp>
       <p:sp>
         <p:nvSpPr>
@@ -3918,7 +3604,7 @@
           <a:bodyPr wrap="square" rtlCol="0" anchor="ctr"/>
           <a:lstStyle/>
           <a:p>
-            <a:pPr indent="0" marL="0">
+            <a:pPr marL="0" indent="0">
               <a:buNone/>
             </a:pPr>
             <a:r>
@@ -3954,7 +3640,7 @@
           <a:bodyPr wrap="square" rtlCol="0" anchor="ctr"/>
           <a:lstStyle/>
           <a:p>
-            <a:pPr algn="r" indent="0" marL="0">
+            <a:pPr marL="0" indent="0" algn="r">
               <a:buNone/>
             </a:pPr>
             <a:r>
@@ -3993,13 +3679,20 @@
             <a:prstDash val="solid"/>
           </a:ln>
           <a:effectLst>
-            <a:outerShdw sx="100000" sy="100000" kx="0" ky="0" algn="bl" rotWithShape="0" blurRad="101600" dist="38100" dir="8100000">
+            <a:outerShdw blurRad="101600" dist="38100" dir="8100000" algn="bl" rotWithShape="0">
               <a:srgbClr val="000000">
                 <a:alpha val="12000"/>
               </a:srgbClr>
             </a:outerShdw>
           </a:effectLst>
         </p:spPr>
+        <p:txBody>
+          <a:bodyPr/>
+          <a:lstStyle/>
+          <a:p>
+            <a:endParaRPr lang="fr-FR"/>
+          </a:p>
+        </p:txBody>
       </p:sp>
       <p:sp>
         <p:nvSpPr>
@@ -4022,7 +3715,7 @@
           <a:bodyPr wrap="square" rtlCol="0" anchor="ctr"/>
           <a:lstStyle/>
           <a:p>
-            <a:pPr algn="ctr" indent="0" marL="0">
+            <a:pPr marL="0" indent="0" algn="ctr">
               <a:buNone/>
             </a:pPr>
             <a:r>
@@ -4058,7 +3751,7 @@
           <a:bodyPr wrap="square" rtlCol="0" anchor="ctr"/>
           <a:lstStyle/>
           <a:p>
-            <a:pPr algn="ctr" indent="0" marL="0">
+            <a:pPr marL="0" indent="0" algn="ctr">
               <a:buNone/>
             </a:pPr>
             <a:r>
@@ -4072,7 +3765,7 @@
             <a:endParaRPr lang="en-US" sz="1100" dirty="0"/>
           </a:p>
           <a:p>
-            <a:pPr algn="ctr" indent="0" marL="0">
+            <a:pPr marL="0" indent="0" algn="ctr">
               <a:buNone/>
             </a:pPr>
             <a:r>
@@ -4111,13 +3804,20 @@
             <a:prstDash val="solid"/>
           </a:ln>
           <a:effectLst>
-            <a:outerShdw sx="100000" sy="100000" kx="0" ky="0" algn="bl" rotWithShape="0" blurRad="101600" dist="38100" dir="8100000">
+            <a:outerShdw blurRad="101600" dist="38100" dir="8100000" algn="bl" rotWithShape="0">
               <a:srgbClr val="000000">
                 <a:alpha val="12000"/>
               </a:srgbClr>
             </a:outerShdw>
           </a:effectLst>
         </p:spPr>
+        <p:txBody>
+          <a:bodyPr/>
+          <a:lstStyle/>
+          <a:p>
+            <a:endParaRPr lang="fr-FR"/>
+          </a:p>
+        </p:txBody>
       </p:sp>
       <p:sp>
         <p:nvSpPr>
@@ -4140,7 +3840,7 @@
           <a:bodyPr wrap="square" rtlCol="0" anchor="ctr"/>
           <a:lstStyle/>
           <a:p>
-            <a:pPr algn="ctr" indent="0" marL="0">
+            <a:pPr marL="0" indent="0" algn="ctr">
               <a:buNone/>
             </a:pPr>
             <a:r>
@@ -4176,7 +3876,7 @@
           <a:bodyPr wrap="square" rtlCol="0" anchor="ctr"/>
           <a:lstStyle/>
           <a:p>
-            <a:pPr algn="ctr" indent="0" marL="0">
+            <a:pPr marL="0" indent="0" algn="ctr">
               <a:buNone/>
             </a:pPr>
             <a:r>
@@ -4190,7 +3890,7 @@
             <a:endParaRPr lang="en-US" sz="1100" dirty="0"/>
           </a:p>
           <a:p>
-            <a:pPr algn="ctr" indent="0" marL="0">
+            <a:pPr marL="0" indent="0" algn="ctr">
               <a:buNone/>
             </a:pPr>
             <a:r>
@@ -4229,13 +3929,20 @@
             <a:prstDash val="solid"/>
           </a:ln>
           <a:effectLst>
-            <a:outerShdw sx="100000" sy="100000" kx="0" ky="0" algn="bl" rotWithShape="0" blurRad="101600" dist="38100" dir="8100000">
+            <a:outerShdw blurRad="101600" dist="38100" dir="8100000" algn="bl" rotWithShape="0">
               <a:srgbClr val="000000">
                 <a:alpha val="12000"/>
               </a:srgbClr>
             </a:outerShdw>
           </a:effectLst>
         </p:spPr>
+        <p:txBody>
+          <a:bodyPr/>
+          <a:lstStyle/>
+          <a:p>
+            <a:endParaRPr lang="fr-FR"/>
+          </a:p>
+        </p:txBody>
       </p:sp>
       <p:sp>
         <p:nvSpPr>
@@ -4258,7 +3965,7 @@
           <a:bodyPr wrap="square" rtlCol="0" anchor="ctr"/>
           <a:lstStyle/>
           <a:p>
-            <a:pPr algn="ctr" indent="0" marL="0">
+            <a:pPr marL="0" indent="0" algn="ctr">
               <a:buNone/>
             </a:pPr>
             <a:r>
@@ -4294,7 +4001,7 @@
           <a:bodyPr wrap="square" rtlCol="0" anchor="ctr"/>
           <a:lstStyle/>
           <a:p>
-            <a:pPr algn="ctr" indent="0" marL="0">
+            <a:pPr marL="0" indent="0" algn="ctr">
               <a:buNone/>
             </a:pPr>
             <a:r>
@@ -4308,7 +4015,7 @@
             <a:endParaRPr lang="en-US" sz="1100" dirty="0"/>
           </a:p>
           <a:p>
-            <a:pPr algn="ctr" indent="0" marL="0">
+            <a:pPr marL="0" indent="0" algn="ctr">
               <a:buNone/>
             </a:pPr>
             <a:r>
@@ -4347,13 +4054,20 @@
             <a:prstDash val="solid"/>
           </a:ln>
           <a:effectLst>
-            <a:outerShdw sx="100000" sy="100000" kx="0" ky="0" algn="bl" rotWithShape="0" blurRad="101600" dist="38100" dir="8100000">
+            <a:outerShdw blurRad="101600" dist="38100" dir="8100000" algn="bl" rotWithShape="0">
               <a:srgbClr val="000000">
                 <a:alpha val="12000"/>
               </a:srgbClr>
             </a:outerShdw>
           </a:effectLst>
         </p:spPr>
+        <p:txBody>
+          <a:bodyPr/>
+          <a:lstStyle/>
+          <a:p>
+            <a:endParaRPr lang="fr-FR"/>
+          </a:p>
+        </p:txBody>
       </p:sp>
       <p:sp>
         <p:nvSpPr>
@@ -4376,7 +4090,7 @@
           <a:bodyPr wrap="square" rtlCol="0" anchor="ctr"/>
           <a:lstStyle/>
           <a:p>
-            <a:pPr algn="ctr" indent="0" marL="0">
+            <a:pPr marL="0" indent="0" algn="ctr">
               <a:buNone/>
             </a:pPr>
             <a:r>
@@ -4412,7 +4126,7 @@
           <a:bodyPr wrap="square" rtlCol="0" anchor="ctr"/>
           <a:lstStyle/>
           <a:p>
-            <a:pPr algn="ctr" indent="0" marL="0">
+            <a:pPr marL="0" indent="0" algn="ctr">
               <a:buNone/>
             </a:pPr>
             <a:r>
@@ -4426,7 +4140,7 @@
             <a:endParaRPr lang="en-US" sz="1100" dirty="0"/>
           </a:p>
           <a:p>
-            <a:pPr algn="ctr" indent="0" marL="0">
+            <a:pPr marL="0" indent="0" algn="ctr">
               <a:buNone/>
             </a:pPr>
             <a:r>
@@ -4465,13 +4179,20 @@
             <a:prstDash val="solid"/>
           </a:ln>
           <a:effectLst>
-            <a:outerShdw sx="100000" sy="100000" kx="0" ky="0" algn="bl" rotWithShape="0" blurRad="101600" dist="38100" dir="8100000">
+            <a:outerShdw blurRad="101600" dist="38100" dir="8100000" algn="bl" rotWithShape="0">
               <a:srgbClr val="000000">
                 <a:alpha val="12000"/>
               </a:srgbClr>
             </a:outerShdw>
           </a:effectLst>
         </p:spPr>
+        <p:txBody>
+          <a:bodyPr/>
+          <a:lstStyle/>
+          <a:p>
+            <a:endParaRPr lang="fr-FR"/>
+          </a:p>
+        </p:txBody>
       </p:sp>
       <p:sp>
         <p:nvSpPr>
@@ -4497,6 +4218,13 @@
             <a:prstDash val="solid"/>
           </a:ln>
         </p:spPr>
+        <p:txBody>
+          <a:bodyPr/>
+          <a:lstStyle/>
+          <a:p>
+            <a:endParaRPr lang="fr-FR"/>
+          </a:p>
+        </p:txBody>
       </p:sp>
       <p:sp>
         <p:nvSpPr>
@@ -4519,7 +4247,7 @@
           <a:bodyPr wrap="square" rtlCol="0" anchor="ctr"/>
           <a:lstStyle/>
           <a:p>
-            <a:pPr indent="0" marL="0">
+            <a:pPr marL="0" indent="0">
               <a:buNone/>
             </a:pPr>
             <a:r>
@@ -4555,7 +4283,7 @@
           <a:bodyPr wrap="square" rtlCol="0" anchor="ctr"/>
           <a:lstStyle/>
           <a:p>
-            <a:pPr indent="0" marL="0">
+            <a:pPr marL="0" indent="0">
               <a:buNone/>
             </a:pPr>
             <a:r>
@@ -4566,9 +4294,6 @@
               </a:rPr>
               <a:t>1. </a:t>
             </a:r>
-            <a:pPr indent="0" marL="0">
-              <a:buNone/>
-            </a:pPr>
             <a:r>
               <a:rPr lang="en-US" sz="1200" dirty="0">
                 <a:solidFill>
@@ -4580,7 +4305,7 @@
             <a:endParaRPr lang="en-US" sz="1200" dirty="0"/>
           </a:p>
           <a:p>
-            <a:pPr indent="0" marL="0">
+            <a:pPr marL="0" indent="0">
               <a:buNone/>
             </a:pPr>
             <a:r>
@@ -4591,9 +4316,6 @@
               </a:rPr>
               <a:t>2. </a:t>
             </a:r>
-            <a:pPr indent="0" marL="0">
-              <a:buNone/>
-            </a:pPr>
             <a:r>
               <a:rPr lang="en-US" sz="1200" dirty="0">
                 <a:solidFill>
@@ -4605,7 +4327,7 @@
             <a:endParaRPr lang="en-US" sz="1200" dirty="0"/>
           </a:p>
           <a:p>
-            <a:pPr indent="0" marL="0">
+            <a:pPr marL="0" indent="0">
               <a:buNone/>
             </a:pPr>
             <a:r>
@@ -4616,9 +4338,6 @@
               </a:rPr>
               <a:t>3. </a:t>
             </a:r>
-            <a:pPr indent="0" marL="0">
-              <a:buNone/>
-            </a:pPr>
             <a:r>
               <a:rPr lang="en-US" sz="1200" dirty="0">
                 <a:solidFill>
@@ -4628,67 +4347,6 @@
               <a:t>La Master Key est injectée via variable d'environnement APP_MASTER_KEY</a:t>
             </a:r>
             <a:endParaRPr lang="en-US" sz="1200" dirty="0"/>
-          </a:p>
-        </p:txBody>
-      </p:sp>
-      <p:sp>
-        <p:nvSpPr>
-          <p:cNvPr id="22" name="Shape 20"/>
-          <p:cNvSpPr/>
-          <p:nvPr/>
-        </p:nvSpPr>
-        <p:spPr>
-          <a:xfrm>
-            <a:off x="0" y="4800600"/>
-            <a:ext cx="9144000" cy="342900"/>
-          </a:xfrm>
-          <a:prstGeom prst="rect">
-            <a:avLst/>
-          </a:prstGeom>
-          <a:solidFill>
-            <a:srgbClr val="1A2B4A"/>
-          </a:solidFill>
-          <a:ln w="12700">
-            <a:solidFill>
-              <a:srgbClr val="1A2B4A"/>
-            </a:solidFill>
-            <a:prstDash val="solid"/>
-          </a:ln>
-        </p:spPr>
-      </p:sp>
-      <p:sp>
-        <p:nvSpPr>
-          <p:cNvPr id="23" name="Text 21"/>
-          <p:cNvSpPr/>
-          <p:nvPr/>
-        </p:nvSpPr>
-        <p:spPr>
-          <a:xfrm>
-            <a:off x="365760" y="4800600"/>
-            <a:ext cx="8412480" cy="342900"/>
-          </a:xfrm>
-          <a:prstGeom prst="rect">
-            <a:avLst/>
-          </a:prstGeom>
-          <a:noFill/>
-          <a:ln/>
-        </p:spPr>
-        <p:txBody>
-          <a:bodyPr wrap="square" rtlCol="0" anchor="ctr"/>
-          <a:lstStyle/>
-          <a:p>
-            <a:pPr indent="0" marL="0">
-              <a:buNone/>
-            </a:pPr>
-            <a:r>
-              <a:rPr lang="en-US" sz="1000" dirty="0">
-                <a:solidFill>
-                  <a:srgbClr val="94A3B8"/>
-                </a:solidFill>
-              </a:rPr>
-              <a:t>TP5 – Password Change &amp; Docker  ·  D. Samfat</a:t>
-            </a:r>
-            <a:endParaRPr lang="en-US" sz="1000" dirty="0"/>
           </a:p>
         </p:txBody>
       </p:sp>
@@ -4708,6 +4366,7 @@
         <a:solidFill>
           <a:srgbClr val="F4F7F9"/>
         </a:solidFill>
+        <a:effectLst/>
       </p:bgPr>
     </p:bg>
     <p:spTree>
@@ -4748,6 +4407,13 @@
             <a:prstDash val="solid"/>
           </a:ln>
         </p:spPr>
+        <p:txBody>
+          <a:bodyPr/>
+          <a:lstStyle/>
+          <a:p>
+            <a:endParaRPr lang="fr-FR"/>
+          </a:p>
+        </p:txBody>
       </p:sp>
       <p:sp>
         <p:nvSpPr>
@@ -4773,6 +4439,13 @@
             <a:prstDash val="solid"/>
           </a:ln>
         </p:spPr>
+        <p:txBody>
+          <a:bodyPr/>
+          <a:lstStyle/>
+          <a:p>
+            <a:endParaRPr lang="fr-FR"/>
+          </a:p>
+        </p:txBody>
       </p:sp>
       <p:sp>
         <p:nvSpPr>
@@ -4795,7 +4468,7 @@
           <a:bodyPr wrap="square" rtlCol="0" anchor="ctr"/>
           <a:lstStyle/>
           <a:p>
-            <a:pPr indent="0" marL="0">
+            <a:pPr marL="0" indent="0">
               <a:buNone/>
             </a:pPr>
             <a:r>
@@ -4831,7 +4504,7 @@
           <a:bodyPr wrap="square" rtlCol="0" anchor="ctr"/>
           <a:lstStyle/>
           <a:p>
-            <a:pPr algn="r" indent="0" marL="0">
+            <a:pPr marL="0" indent="0" algn="r">
               <a:buNone/>
             </a:pPr>
             <a:r>
@@ -4870,13 +4543,20 @@
             <a:prstDash val="solid"/>
           </a:ln>
           <a:effectLst>
-            <a:outerShdw sx="100000" sy="100000" kx="0" ky="0" algn="bl" rotWithShape="0" blurRad="101600" dist="38100" dir="8100000">
+            <a:outerShdw blurRad="101600" dist="38100" dir="8100000" algn="bl" rotWithShape="0">
               <a:srgbClr val="000000">
                 <a:alpha val="12000"/>
               </a:srgbClr>
             </a:outerShdw>
           </a:effectLst>
         </p:spPr>
+        <p:txBody>
+          <a:bodyPr/>
+          <a:lstStyle/>
+          <a:p>
+            <a:endParaRPr lang="fr-FR"/>
+          </a:p>
+        </p:txBody>
       </p:sp>
       <p:sp>
         <p:nvSpPr>
@@ -4902,6 +4582,13 @@
             <a:prstDash val="solid"/>
           </a:ln>
         </p:spPr>
+        <p:txBody>
+          <a:bodyPr/>
+          <a:lstStyle/>
+          <a:p>
+            <a:endParaRPr lang="fr-FR"/>
+          </a:p>
+        </p:txBody>
       </p:sp>
       <p:sp>
         <p:nvSpPr>
@@ -4924,7 +4611,7 @@
           <a:bodyPr wrap="square" lIns="0" tIns="0" rIns="0" bIns="0" rtlCol="0" anchor="ctr"/>
           <a:lstStyle/>
           <a:p>
-            <a:pPr algn="ctr" indent="0" marL="0">
+            <a:pPr marL="0" indent="0" algn="ctr">
               <a:buNone/>
             </a:pPr>
             <a:r>
@@ -4960,7 +4647,7 @@
           <a:bodyPr wrap="square" rtlCol="0" anchor="ctr"/>
           <a:lstStyle/>
           <a:p>
-            <a:pPr indent="0" marL="0">
+            <a:pPr marL="0" indent="0">
               <a:buNone/>
             </a:pPr>
             <a:r>
@@ -4996,7 +4683,7 @@
           <a:bodyPr wrap="square" rtlCol="0" anchor="ctr"/>
           <a:lstStyle/>
           <a:p>
-            <a:pPr indent="0" marL="0">
+            <a:pPr marL="0" indent="0">
               <a:buNone/>
             </a:pPr>
             <a:r>
@@ -5035,13 +4722,20 @@
             <a:prstDash val="solid"/>
           </a:ln>
           <a:effectLst>
-            <a:outerShdw sx="100000" sy="100000" kx="0" ky="0" algn="bl" rotWithShape="0" blurRad="101600" dist="38100" dir="8100000">
+            <a:outerShdw blurRad="101600" dist="38100" dir="8100000" algn="bl" rotWithShape="0">
               <a:srgbClr val="000000">
                 <a:alpha val="12000"/>
               </a:srgbClr>
             </a:outerShdw>
           </a:effectLst>
         </p:spPr>
+        <p:txBody>
+          <a:bodyPr/>
+          <a:lstStyle/>
+          <a:p>
+            <a:endParaRPr lang="fr-FR"/>
+          </a:p>
+        </p:txBody>
       </p:sp>
       <p:sp>
         <p:nvSpPr>
@@ -5067,6 +4761,13 @@
             <a:prstDash val="solid"/>
           </a:ln>
         </p:spPr>
+        <p:txBody>
+          <a:bodyPr/>
+          <a:lstStyle/>
+          <a:p>
+            <a:endParaRPr lang="fr-FR"/>
+          </a:p>
+        </p:txBody>
       </p:sp>
       <p:sp>
         <p:nvSpPr>
@@ -5089,7 +4790,7 @@
           <a:bodyPr wrap="square" lIns="0" tIns="0" rIns="0" bIns="0" rtlCol="0" anchor="ctr"/>
           <a:lstStyle/>
           <a:p>
-            <a:pPr algn="ctr" indent="0" marL="0">
+            <a:pPr marL="0" indent="0" algn="ctr">
               <a:buNone/>
             </a:pPr>
             <a:r>
@@ -5125,7 +4826,7 @@
           <a:bodyPr wrap="square" rtlCol="0" anchor="ctr"/>
           <a:lstStyle/>
           <a:p>
-            <a:pPr indent="0" marL="0">
+            <a:pPr marL="0" indent="0">
               <a:buNone/>
             </a:pPr>
             <a:r>
@@ -5161,7 +4862,7 @@
           <a:bodyPr wrap="square" rtlCol="0" anchor="ctr"/>
           <a:lstStyle/>
           <a:p>
-            <a:pPr indent="0" marL="0">
+            <a:pPr marL="0" indent="0">
               <a:buNone/>
             </a:pPr>
             <a:r>
@@ -5200,13 +4901,20 @@
             <a:prstDash val="solid"/>
           </a:ln>
           <a:effectLst>
-            <a:outerShdw sx="100000" sy="100000" kx="0" ky="0" algn="bl" rotWithShape="0" blurRad="101600" dist="38100" dir="8100000">
+            <a:outerShdw blurRad="101600" dist="38100" dir="8100000" algn="bl" rotWithShape="0">
               <a:srgbClr val="000000">
                 <a:alpha val="12000"/>
               </a:srgbClr>
             </a:outerShdw>
           </a:effectLst>
         </p:spPr>
+        <p:txBody>
+          <a:bodyPr/>
+          <a:lstStyle/>
+          <a:p>
+            <a:endParaRPr lang="fr-FR"/>
+          </a:p>
+        </p:txBody>
       </p:sp>
       <p:sp>
         <p:nvSpPr>
@@ -5232,6 +4940,13 @@
             <a:prstDash val="solid"/>
           </a:ln>
         </p:spPr>
+        <p:txBody>
+          <a:bodyPr/>
+          <a:lstStyle/>
+          <a:p>
+            <a:endParaRPr lang="fr-FR"/>
+          </a:p>
+        </p:txBody>
       </p:sp>
       <p:sp>
         <p:nvSpPr>
@@ -5254,7 +4969,7 @@
           <a:bodyPr wrap="square" lIns="0" tIns="0" rIns="0" bIns="0" rtlCol="0" anchor="ctr"/>
           <a:lstStyle/>
           <a:p>
-            <a:pPr algn="ctr" indent="0" marL="0">
+            <a:pPr marL="0" indent="0" algn="ctr">
               <a:buNone/>
             </a:pPr>
             <a:r>
@@ -5290,7 +5005,7 @@
           <a:bodyPr wrap="square" rtlCol="0" anchor="ctr"/>
           <a:lstStyle/>
           <a:p>
-            <a:pPr indent="0" marL="0">
+            <a:pPr marL="0" indent="0">
               <a:buNone/>
             </a:pPr>
             <a:r>
@@ -5326,7 +5041,7 @@
           <a:bodyPr wrap="square" rtlCol="0" anchor="ctr"/>
           <a:lstStyle/>
           <a:p>
-            <a:pPr indent="0" marL="0">
+            <a:pPr marL="0" indent="0">
               <a:buNone/>
             </a:pPr>
             <a:r>
@@ -5365,13 +5080,20 @@
             <a:prstDash val="solid"/>
           </a:ln>
           <a:effectLst>
-            <a:outerShdw sx="100000" sy="100000" kx="0" ky="0" algn="bl" rotWithShape="0" blurRad="101600" dist="38100" dir="8100000">
+            <a:outerShdw blurRad="101600" dist="38100" dir="8100000" algn="bl" rotWithShape="0">
               <a:srgbClr val="000000">
                 <a:alpha val="12000"/>
               </a:srgbClr>
             </a:outerShdw>
           </a:effectLst>
         </p:spPr>
+        <p:txBody>
+          <a:bodyPr/>
+          <a:lstStyle/>
+          <a:p>
+            <a:endParaRPr lang="fr-FR"/>
+          </a:p>
+        </p:txBody>
       </p:sp>
       <p:sp>
         <p:nvSpPr>
@@ -5397,6 +5119,13 @@
             <a:prstDash val="solid"/>
           </a:ln>
         </p:spPr>
+        <p:txBody>
+          <a:bodyPr/>
+          <a:lstStyle/>
+          <a:p>
+            <a:endParaRPr lang="fr-FR"/>
+          </a:p>
+        </p:txBody>
       </p:sp>
       <p:sp>
         <p:nvSpPr>
@@ -5419,7 +5148,7 @@
           <a:bodyPr wrap="square" lIns="0" tIns="0" rIns="0" bIns="0" rtlCol="0" anchor="ctr"/>
           <a:lstStyle/>
           <a:p>
-            <a:pPr algn="ctr" indent="0" marL="0">
+            <a:pPr marL="0" indent="0" algn="ctr">
               <a:buNone/>
             </a:pPr>
             <a:r>
@@ -5455,7 +5184,7 @@
           <a:bodyPr wrap="square" rtlCol="0" anchor="ctr"/>
           <a:lstStyle/>
           <a:p>
-            <a:pPr indent="0" marL="0">
+            <a:pPr marL="0" indent="0">
               <a:buNone/>
             </a:pPr>
             <a:r>
@@ -5491,7 +5220,7 @@
           <a:bodyPr wrap="square" rtlCol="0" anchor="ctr"/>
           <a:lstStyle/>
           <a:p>
-            <a:pPr indent="0" marL="0">
+            <a:pPr marL="0" indent="0">
               <a:buNone/>
             </a:pPr>
             <a:r>
@@ -5530,13 +5259,20 @@
             <a:prstDash val="solid"/>
           </a:ln>
           <a:effectLst>
-            <a:outerShdw sx="100000" sy="100000" kx="0" ky="0" algn="bl" rotWithShape="0" blurRad="101600" dist="38100" dir="8100000">
+            <a:outerShdw blurRad="101600" dist="38100" dir="8100000" algn="bl" rotWithShape="0">
               <a:srgbClr val="000000">
                 <a:alpha val="12000"/>
               </a:srgbClr>
             </a:outerShdw>
           </a:effectLst>
         </p:spPr>
+        <p:txBody>
+          <a:bodyPr/>
+          <a:lstStyle/>
+          <a:p>
+            <a:endParaRPr lang="fr-FR"/>
+          </a:p>
+        </p:txBody>
       </p:sp>
       <p:sp>
         <p:nvSpPr>
@@ -5562,6 +5298,13 @@
             <a:prstDash val="solid"/>
           </a:ln>
         </p:spPr>
+        <p:txBody>
+          <a:bodyPr/>
+          <a:lstStyle/>
+          <a:p>
+            <a:endParaRPr lang="fr-FR"/>
+          </a:p>
+        </p:txBody>
       </p:sp>
       <p:sp>
         <p:nvSpPr>
@@ -5584,7 +5327,7 @@
           <a:bodyPr wrap="square" lIns="0" tIns="0" rIns="0" bIns="0" rtlCol="0" anchor="ctr"/>
           <a:lstStyle/>
           <a:p>
-            <a:pPr algn="ctr" indent="0" marL="0">
+            <a:pPr marL="0" indent="0" algn="ctr">
               <a:buNone/>
             </a:pPr>
             <a:r>
@@ -5620,7 +5363,7 @@
           <a:bodyPr wrap="square" rtlCol="0" anchor="ctr"/>
           <a:lstStyle/>
           <a:p>
-            <a:pPr indent="0" marL="0">
+            <a:pPr marL="0" indent="0">
               <a:buNone/>
             </a:pPr>
             <a:r>
@@ -5656,7 +5399,7 @@
           <a:bodyPr wrap="square" rtlCol="0" anchor="ctr"/>
           <a:lstStyle/>
           <a:p>
-            <a:pPr indent="0" marL="0">
+            <a:pPr marL="0" indent="0">
               <a:buNone/>
             </a:pPr>
             <a:r>
@@ -5668,67 +5411,6 @@
               <a:t>Email non trouvé dans la base → exception levée</a:t>
             </a:r>
             <a:endParaRPr lang="en-US" sz="1100" dirty="0"/>
-          </a:p>
-        </p:txBody>
-      </p:sp>
-      <p:sp>
-        <p:nvSpPr>
-          <p:cNvPr id="31" name="Shape 29"/>
-          <p:cNvSpPr/>
-          <p:nvPr/>
-        </p:nvSpPr>
-        <p:spPr>
-          <a:xfrm>
-            <a:off x="0" y="4800600"/>
-            <a:ext cx="9144000" cy="342900"/>
-          </a:xfrm>
-          <a:prstGeom prst="rect">
-            <a:avLst/>
-          </a:prstGeom>
-          <a:solidFill>
-            <a:srgbClr val="1A2B4A"/>
-          </a:solidFill>
-          <a:ln w="12700">
-            <a:solidFill>
-              <a:srgbClr val="1A2B4A"/>
-            </a:solidFill>
-            <a:prstDash val="solid"/>
-          </a:ln>
-        </p:spPr>
-      </p:sp>
-      <p:sp>
-        <p:nvSpPr>
-          <p:cNvPr id="32" name="Text 30"/>
-          <p:cNvSpPr/>
-          <p:nvPr/>
-        </p:nvSpPr>
-        <p:spPr>
-          <a:xfrm>
-            <a:off x="365760" y="4800600"/>
-            <a:ext cx="8412480" cy="342900"/>
-          </a:xfrm>
-          <a:prstGeom prst="rect">
-            <a:avLst/>
-          </a:prstGeom>
-          <a:noFill/>
-          <a:ln/>
-        </p:spPr>
-        <p:txBody>
-          <a:bodyPr wrap="square" rtlCol="0" anchor="ctr"/>
-          <a:lstStyle/>
-          <a:p>
-            <a:pPr indent="0" marL="0">
-              <a:buNone/>
-            </a:pPr>
-            <a:r>
-              <a:rPr lang="en-US" sz="1000" dirty="0">
-                <a:solidFill>
-                  <a:srgbClr val="94A3B8"/>
-                </a:solidFill>
-              </a:rPr>
-              <a:t>TP5 – Password Change &amp; Docker  ·  D. Samfat</a:t>
-            </a:r>
-            <a:endParaRPr lang="en-US" sz="1000" dirty="0"/>
           </a:p>
         </p:txBody>
       </p:sp>
@@ -5748,6 +5430,7 @@
         <a:solidFill>
           <a:srgbClr val="F4F7F9"/>
         </a:solidFill>
+        <a:effectLst/>
       </p:bgPr>
     </p:bg>
     <p:spTree>
@@ -5788,6 +5471,13 @@
             <a:prstDash val="solid"/>
           </a:ln>
         </p:spPr>
+        <p:txBody>
+          <a:bodyPr/>
+          <a:lstStyle/>
+          <a:p>
+            <a:endParaRPr lang="fr-FR"/>
+          </a:p>
+        </p:txBody>
       </p:sp>
       <p:sp>
         <p:nvSpPr>
@@ -5813,6 +5503,13 @@
             <a:prstDash val="solid"/>
           </a:ln>
         </p:spPr>
+        <p:txBody>
+          <a:bodyPr/>
+          <a:lstStyle/>
+          <a:p>
+            <a:endParaRPr lang="fr-FR"/>
+          </a:p>
+        </p:txBody>
       </p:sp>
       <p:sp>
         <p:nvSpPr>
@@ -5835,7 +5532,7 @@
           <a:bodyPr wrap="square" rtlCol="0" anchor="ctr"/>
           <a:lstStyle/>
           <a:p>
-            <a:pPr indent="0" marL="0">
+            <a:pPr marL="0" indent="0">
               <a:buNone/>
             </a:pPr>
             <a:r>
@@ -5871,7 +5568,7 @@
           <a:bodyPr wrap="square" rtlCol="0" anchor="ctr"/>
           <a:lstStyle/>
           <a:p>
-            <a:pPr algn="r" indent="0" marL="0">
+            <a:pPr marL="0" indent="0" algn="r">
               <a:buNone/>
             </a:pPr>
             <a:r>
@@ -5910,13 +5607,20 @@
             <a:prstDash val="solid"/>
           </a:ln>
           <a:effectLst>
-            <a:outerShdw sx="100000" sy="100000" kx="0" ky="0" algn="bl" rotWithShape="0" blurRad="101600" dist="38100" dir="8100000">
+            <a:outerShdw blurRad="101600" dist="38100" dir="8100000" algn="bl" rotWithShape="0">
               <a:srgbClr val="000000">
                 <a:alpha val="12000"/>
               </a:srgbClr>
             </a:outerShdw>
           </a:effectLst>
         </p:spPr>
+        <p:txBody>
+          <a:bodyPr/>
+          <a:lstStyle/>
+          <a:p>
+            <a:endParaRPr lang="fr-FR"/>
+          </a:p>
+        </p:txBody>
       </p:sp>
       <p:sp>
         <p:nvSpPr>
@@ -5942,6 +5646,13 @@
             <a:prstDash val="solid"/>
           </a:ln>
         </p:spPr>
+        <p:txBody>
+          <a:bodyPr/>
+          <a:lstStyle/>
+          <a:p>
+            <a:endParaRPr lang="fr-FR"/>
+          </a:p>
+        </p:txBody>
       </p:sp>
       <p:sp>
         <p:nvSpPr>
@@ -5964,7 +5675,7 @@
           <a:bodyPr wrap="square" lIns="0" tIns="0" rIns="0" bIns="0" rtlCol="0" anchor="ctr"/>
           <a:lstStyle/>
           <a:p>
-            <a:pPr indent="0" marL="0">
+            <a:pPr marL="0" indent="0">
               <a:buNone/>
             </a:pPr>
             <a:r>
@@ -6003,7 +5714,7 @@
           <a:bodyPr wrap="square" rtlCol="0" anchor="ctr"/>
           <a:lstStyle/>
           <a:p>
-            <a:pPr indent="0" marL="0">
+            <a:pPr marL="0" indent="0">
               <a:buNone/>
             </a:pPr>
             <a:r>
@@ -6020,7 +5731,7 @@
             <a:endParaRPr lang="en-US" sz="1200" dirty="0"/>
           </a:p>
           <a:p>
-            <a:pPr indent="0" marL="0">
+            <a:pPr marL="0" indent="0">
               <a:buNone/>
             </a:pPr>
             <a:r>
@@ -6037,7 +5748,7 @@
             <a:endParaRPr lang="en-US" sz="1200" dirty="0"/>
           </a:p>
           <a:p>
-            <a:pPr indent="0" marL="0">
+            <a:pPr marL="0" indent="0">
               <a:buNone/>
             </a:pPr>
             <a:r>
@@ -6054,7 +5765,7 @@
             <a:endParaRPr lang="en-US" sz="1200" dirty="0"/>
           </a:p>
           <a:p>
-            <a:pPr indent="0" marL="0">
+            <a:pPr marL="0" indent="0">
               <a:buNone/>
             </a:pPr>
             <a:r>
@@ -6071,7 +5782,7 @@
             <a:endParaRPr lang="en-US" sz="1200" dirty="0"/>
           </a:p>
           <a:p>
-            <a:pPr indent="0" marL="0">
+            <a:pPr marL="0" indent="0">
               <a:buNone/>
             </a:pPr>
             <a:r>
@@ -6088,7 +5799,7 @@
             <a:endParaRPr lang="en-US" sz="1200" dirty="0"/>
           </a:p>
           <a:p>
-            <a:pPr indent="0" marL="0">
+            <a:pPr marL="0" indent="0">
               <a:buNone/>
             </a:pPr>
             <a:r>
@@ -6105,7 +5816,7 @@
             <a:endParaRPr lang="en-US" sz="1200" dirty="0"/>
           </a:p>
           <a:p>
-            <a:pPr indent="0" marL="0">
+            <a:pPr marL="0" indent="0">
               <a:buNone/>
             </a:pPr>
             <a:r>
@@ -6122,7 +5833,7 @@
             <a:endParaRPr lang="en-US" sz="1200" dirty="0"/>
           </a:p>
           <a:p>
-            <a:pPr indent="0" marL="0">
+            <a:pPr marL="0" indent="0">
               <a:buNone/>
             </a:pPr>
             <a:r>
@@ -6139,7 +5850,7 @@
             <a:endParaRPr lang="en-US" sz="1200" dirty="0"/>
           </a:p>
           <a:p>
-            <a:pPr indent="0" marL="0">
+            <a:pPr marL="0" indent="0">
               <a:buNone/>
             </a:pPr>
             <a:r>
@@ -6181,13 +5892,20 @@
             <a:prstDash val="solid"/>
           </a:ln>
           <a:effectLst>
-            <a:outerShdw sx="100000" sy="100000" kx="0" ky="0" algn="bl" rotWithShape="0" blurRad="101600" dist="38100" dir="8100000">
+            <a:outerShdw blurRad="101600" dist="38100" dir="8100000" algn="bl" rotWithShape="0">
               <a:srgbClr val="000000">
                 <a:alpha val="12000"/>
               </a:srgbClr>
             </a:outerShdw>
           </a:effectLst>
         </p:spPr>
+        <p:txBody>
+          <a:bodyPr/>
+          <a:lstStyle/>
+          <a:p>
+            <a:endParaRPr lang="fr-FR"/>
+          </a:p>
+        </p:txBody>
       </p:sp>
       <p:sp>
         <p:nvSpPr>
@@ -6213,6 +5931,13 @@
             <a:prstDash val="solid"/>
           </a:ln>
         </p:spPr>
+        <p:txBody>
+          <a:bodyPr/>
+          <a:lstStyle/>
+          <a:p>
+            <a:endParaRPr lang="fr-FR"/>
+          </a:p>
+        </p:txBody>
       </p:sp>
       <p:sp>
         <p:nvSpPr>
@@ -6235,7 +5960,7 @@
           <a:bodyPr wrap="square" lIns="0" tIns="0" rIns="0" bIns="0" rtlCol="0" anchor="ctr"/>
           <a:lstStyle/>
           <a:p>
-            <a:pPr indent="0" marL="0">
+            <a:pPr marL="0" indent="0">
               <a:buNone/>
             </a:pPr>
             <a:r>
@@ -6274,6 +5999,13 @@
             <a:prstDash val="solid"/>
           </a:ln>
         </p:spPr>
+        <p:txBody>
+          <a:bodyPr/>
+          <a:lstStyle/>
+          <a:p>
+            <a:endParaRPr lang="fr-FR"/>
+          </a:p>
+        </p:txBody>
       </p:sp>
       <p:sp>
         <p:nvSpPr>
@@ -6296,7 +6028,7 @@
           <a:bodyPr wrap="square" lIns="0" tIns="0" rIns="0" bIns="0" rtlCol="0" anchor="ctr"/>
           <a:lstStyle/>
           <a:p>
-            <a:pPr algn="ctr" indent="0" marL="0">
+            <a:pPr marL="0" indent="0" algn="ctr">
               <a:buNone/>
             </a:pPr>
             <a:r>
@@ -6335,7 +6067,7 @@
           <a:bodyPr wrap="square" rtlCol="0" anchor="ctr"/>
           <a:lstStyle/>
           <a:p>
-            <a:pPr indent="0" marL="0">
+            <a:pPr marL="0" indent="0">
               <a:buNone/>
             </a:pPr>
             <a:r>
@@ -6374,13 +6106,20 @@
             <a:prstDash val="solid"/>
           </a:ln>
           <a:effectLst>
-            <a:outerShdw sx="100000" sy="100000" kx="0" ky="0" algn="bl" rotWithShape="0" blurRad="101600" dist="38100" dir="8100000">
+            <a:outerShdw blurRad="101600" dist="38100" dir="8100000" algn="bl" rotWithShape="0">
               <a:srgbClr val="000000">
                 <a:alpha val="12000"/>
               </a:srgbClr>
             </a:outerShdw>
           </a:effectLst>
         </p:spPr>
+        <p:txBody>
+          <a:bodyPr/>
+          <a:lstStyle/>
+          <a:p>
+            <a:endParaRPr lang="fr-FR"/>
+          </a:p>
+        </p:txBody>
       </p:sp>
       <p:sp>
         <p:nvSpPr>
@@ -6406,6 +6145,13 @@
             <a:prstDash val="solid"/>
           </a:ln>
         </p:spPr>
+        <p:txBody>
+          <a:bodyPr/>
+          <a:lstStyle/>
+          <a:p>
+            <a:endParaRPr lang="fr-FR"/>
+          </a:p>
+        </p:txBody>
       </p:sp>
       <p:sp>
         <p:nvSpPr>
@@ -6428,7 +6174,7 @@
           <a:bodyPr wrap="square" lIns="0" tIns="0" rIns="0" bIns="0" rtlCol="0" anchor="ctr"/>
           <a:lstStyle/>
           <a:p>
-            <a:pPr indent="0" marL="0">
+            <a:pPr marL="0" indent="0">
               <a:buNone/>
             </a:pPr>
             <a:r>
@@ -6467,6 +6213,13 @@
             <a:prstDash val="solid"/>
           </a:ln>
         </p:spPr>
+        <p:txBody>
+          <a:bodyPr/>
+          <a:lstStyle/>
+          <a:p>
+            <a:endParaRPr lang="fr-FR"/>
+          </a:p>
+        </p:txBody>
       </p:sp>
       <p:sp>
         <p:nvSpPr>
@@ -6489,7 +6242,7 @@
           <a:bodyPr wrap="square" rtlCol="0" anchor="ctr"/>
           <a:lstStyle/>
           <a:p>
-            <a:pPr indent="0" marL="0">
+            <a:pPr marL="0" indent="0">
               <a:buNone/>
             </a:pPr>
             <a:r>
@@ -6506,7 +6259,7 @@
             <a:endParaRPr lang="en-US" sz="1000" dirty="0"/>
           </a:p>
           <a:p>
-            <a:pPr indent="0" marL="0">
+            <a:pPr marL="0" indent="0">
               <a:buNone/>
             </a:pPr>
             <a:r>
@@ -6523,7 +6276,7 @@
             <a:endParaRPr lang="en-US" sz="1000" dirty="0"/>
           </a:p>
           <a:p>
-            <a:pPr indent="0" marL="0">
+            <a:pPr marL="0" indent="0">
               <a:buNone/>
             </a:pPr>
             <a:r>
@@ -6562,7 +6315,7 @@
           <a:bodyPr wrap="square" rtlCol="0" anchor="ctr"/>
           <a:lstStyle/>
           <a:p>
-            <a:pPr indent="0" marL="0">
+            <a:pPr marL="0" indent="0">
               <a:buNone/>
             </a:pPr>
             <a:r>
@@ -6574,67 +6327,6 @@
               <a:t>Accès : http://localhost:8080</a:t>
             </a:r>
             <a:endParaRPr lang="en-US" sz="1100" dirty="0"/>
-          </a:p>
-        </p:txBody>
-      </p:sp>
-      <p:sp>
-        <p:nvSpPr>
-          <p:cNvPr id="22" name="Shape 20"/>
-          <p:cNvSpPr/>
-          <p:nvPr/>
-        </p:nvSpPr>
-        <p:spPr>
-          <a:xfrm>
-            <a:off x="0" y="4800600"/>
-            <a:ext cx="9144000" cy="342900"/>
-          </a:xfrm>
-          <a:prstGeom prst="rect">
-            <a:avLst/>
-          </a:prstGeom>
-          <a:solidFill>
-            <a:srgbClr val="1A2B4A"/>
-          </a:solidFill>
-          <a:ln w="12700">
-            <a:solidFill>
-              <a:srgbClr val="1A2B4A"/>
-            </a:solidFill>
-            <a:prstDash val="solid"/>
-          </a:ln>
-        </p:spPr>
-      </p:sp>
-      <p:sp>
-        <p:nvSpPr>
-          <p:cNvPr id="23" name="Text 21"/>
-          <p:cNvSpPr/>
-          <p:nvPr/>
-        </p:nvSpPr>
-        <p:spPr>
-          <a:xfrm>
-            <a:off x="365760" y="4800600"/>
-            <a:ext cx="8412480" cy="342900"/>
-          </a:xfrm>
-          <a:prstGeom prst="rect">
-            <a:avLst/>
-          </a:prstGeom>
-          <a:noFill/>
-          <a:ln/>
-        </p:spPr>
-        <p:txBody>
-          <a:bodyPr wrap="square" rtlCol="0" anchor="ctr"/>
-          <a:lstStyle/>
-          <a:p>
-            <a:pPr indent="0" marL="0">
-              <a:buNone/>
-            </a:pPr>
-            <a:r>
-              <a:rPr lang="en-US" sz="1000" dirty="0">
-                <a:solidFill>
-                  <a:srgbClr val="94A3B8"/>
-                </a:solidFill>
-              </a:rPr>
-              <a:t>TP5 – Password Change &amp; Docker  ·  D. Samfat</a:t>
-            </a:r>
-            <a:endParaRPr lang="en-US" sz="1000" dirty="0"/>
           </a:p>
         </p:txBody>
       </p:sp>
@@ -6654,6 +6346,7 @@
         <a:solidFill>
           <a:srgbClr val="F4F7F9"/>
         </a:solidFill>
+        <a:effectLst/>
       </p:bgPr>
     </p:bg>
     <p:spTree>
@@ -6694,6 +6387,13 @@
             <a:prstDash val="solid"/>
           </a:ln>
         </p:spPr>
+        <p:txBody>
+          <a:bodyPr/>
+          <a:lstStyle/>
+          <a:p>
+            <a:endParaRPr lang="fr-FR"/>
+          </a:p>
+        </p:txBody>
       </p:sp>
       <p:sp>
         <p:nvSpPr>
@@ -6719,6 +6419,13 @@
             <a:prstDash val="solid"/>
           </a:ln>
         </p:spPr>
+        <p:txBody>
+          <a:bodyPr/>
+          <a:lstStyle/>
+          <a:p>
+            <a:endParaRPr lang="fr-FR"/>
+          </a:p>
+        </p:txBody>
       </p:sp>
       <p:sp>
         <p:nvSpPr>
@@ -6741,7 +6448,7 @@
           <a:bodyPr wrap="square" rtlCol="0" anchor="ctr"/>
           <a:lstStyle/>
           <a:p>
-            <a:pPr indent="0" marL="0">
+            <a:pPr marL="0" indent="0">
               <a:buNone/>
             </a:pPr>
             <a:r>
@@ -6777,7 +6484,7 @@
           <a:bodyPr wrap="square" rtlCol="0" anchor="ctr"/>
           <a:lstStyle/>
           <a:p>
-            <a:pPr algn="r" indent="0" marL="0">
+            <a:pPr marL="0" indent="0" algn="r">
               <a:buNone/>
             </a:pPr>
             <a:r>
@@ -6816,13 +6523,20 @@
             <a:prstDash val="solid"/>
           </a:ln>
           <a:effectLst>
-            <a:outerShdw sx="100000" sy="100000" kx="0" ky="0" algn="bl" rotWithShape="0" blurRad="101600" dist="38100" dir="8100000">
+            <a:outerShdw blurRad="101600" dist="38100" dir="8100000" algn="bl" rotWithShape="0">
               <a:srgbClr val="000000">
                 <a:alpha val="12000"/>
               </a:srgbClr>
             </a:outerShdw>
           </a:effectLst>
         </p:spPr>
+        <p:txBody>
+          <a:bodyPr/>
+          <a:lstStyle/>
+          <a:p>
+            <a:endParaRPr lang="fr-FR"/>
+          </a:p>
+        </p:txBody>
       </p:sp>
       <p:sp>
         <p:nvSpPr>
@@ -6845,7 +6559,7 @@
           <a:bodyPr wrap="square" rtlCol="0" anchor="ctr"/>
           <a:lstStyle/>
           <a:p>
-            <a:pPr algn="ctr" indent="0" marL="0">
+            <a:pPr marL="0" indent="0" algn="ctr">
               <a:buNone/>
             </a:pPr>
             <a:r>
@@ -6881,7 +6595,7 @@
           <a:bodyPr wrap="square" rtlCol="0" anchor="ctr"/>
           <a:lstStyle/>
           <a:p>
-            <a:pPr algn="ctr" indent="0" marL="0">
+            <a:pPr marL="0" indent="0" algn="ctr">
               <a:buNone/>
             </a:pPr>
             <a:r>
@@ -6895,7 +6609,7 @@
             <a:endParaRPr lang="en-US" sz="1000" dirty="0"/>
           </a:p>
           <a:p>
-            <a:pPr algn="ctr" indent="0" marL="0">
+            <a:pPr marL="0" indent="0" algn="ctr">
               <a:buNone/>
             </a:pPr>
             <a:r>
@@ -6934,6 +6648,13 @@
             <a:prstDash val="solid"/>
           </a:ln>
         </p:spPr>
+        <p:txBody>
+          <a:bodyPr/>
+          <a:lstStyle/>
+          <a:p>
+            <a:endParaRPr lang="fr-FR"/>
+          </a:p>
+        </p:txBody>
       </p:sp>
       <p:sp>
         <p:nvSpPr>
@@ -6943,7 +6664,7 @@
         </p:nvSpPr>
         <p:spPr>
           <a:xfrm>
-            <a:off x="2267712" y="1554480"/>
+            <a:off x="2363724" y="1581912"/>
             <a:ext cx="182880" cy="365760"/>
           </a:xfrm>
           <a:prstGeom prst="rect">
@@ -6956,7 +6677,7 @@
           <a:bodyPr wrap="square" rtlCol="0" anchor="ctr"/>
           <a:lstStyle/>
           <a:p>
-            <a:pPr algn="ctr" indent="0" marL="0">
+            <a:pPr marL="0" indent="0" algn="ctr">
               <a:buNone/>
             </a:pPr>
             <a:r>
@@ -6995,13 +6716,20 @@
             <a:prstDash val="solid"/>
           </a:ln>
           <a:effectLst>
-            <a:outerShdw sx="100000" sy="100000" kx="0" ky="0" algn="bl" rotWithShape="0" blurRad="101600" dist="38100" dir="8100000">
+            <a:outerShdw blurRad="101600" dist="38100" dir="8100000" algn="bl" rotWithShape="0">
               <a:srgbClr val="000000">
                 <a:alpha val="12000"/>
               </a:srgbClr>
             </a:outerShdw>
           </a:effectLst>
         </p:spPr>
+        <p:txBody>
+          <a:bodyPr/>
+          <a:lstStyle/>
+          <a:p>
+            <a:endParaRPr lang="fr-FR"/>
+          </a:p>
+        </p:txBody>
       </p:sp>
       <p:sp>
         <p:nvSpPr>
@@ -7024,7 +6752,7 @@
           <a:bodyPr wrap="square" rtlCol="0" anchor="ctr"/>
           <a:lstStyle/>
           <a:p>
-            <a:pPr algn="ctr" indent="0" marL="0">
+            <a:pPr marL="0" indent="0" algn="ctr">
               <a:buNone/>
             </a:pPr>
             <a:r>
@@ -7060,7 +6788,7 @@
           <a:bodyPr wrap="square" rtlCol="0" anchor="ctr"/>
           <a:lstStyle/>
           <a:p>
-            <a:pPr algn="ctr" indent="0" marL="0">
+            <a:pPr marL="0" indent="0" algn="ctr">
               <a:buNone/>
             </a:pPr>
             <a:r>
@@ -7074,7 +6802,7 @@
             <a:endParaRPr lang="en-US" sz="1000" dirty="0"/>
           </a:p>
           <a:p>
-            <a:pPr algn="ctr" indent="0" marL="0">
+            <a:pPr marL="0" indent="0" algn="ctr">
               <a:buNone/>
             </a:pPr>
             <a:r>
@@ -7113,6 +6841,13 @@
             <a:prstDash val="solid"/>
           </a:ln>
         </p:spPr>
+        <p:txBody>
+          <a:bodyPr/>
+          <a:lstStyle/>
+          <a:p>
+            <a:endParaRPr lang="fr-FR"/>
+          </a:p>
+        </p:txBody>
       </p:sp>
       <p:sp>
         <p:nvSpPr>
@@ -7122,7 +6857,7 @@
         </p:nvSpPr>
         <p:spPr>
           <a:xfrm>
-            <a:off x="4416552" y="1554480"/>
+            <a:off x="4503420" y="1572768"/>
             <a:ext cx="182880" cy="365760"/>
           </a:xfrm>
           <a:prstGeom prst="rect">
@@ -7135,7 +6870,7 @@
           <a:bodyPr wrap="square" rtlCol="0" anchor="ctr"/>
           <a:lstStyle/>
           <a:p>
-            <a:pPr algn="ctr" indent="0" marL="0">
+            <a:pPr marL="0" indent="0" algn="ctr">
               <a:buNone/>
             </a:pPr>
             <a:r>
@@ -7174,13 +6909,20 @@
             <a:prstDash val="solid"/>
           </a:ln>
           <a:effectLst>
-            <a:outerShdw sx="100000" sy="100000" kx="0" ky="0" algn="bl" rotWithShape="0" blurRad="101600" dist="38100" dir="8100000">
+            <a:outerShdw blurRad="101600" dist="38100" dir="8100000" algn="bl" rotWithShape="0">
               <a:srgbClr val="000000">
                 <a:alpha val="12000"/>
               </a:srgbClr>
             </a:outerShdw>
           </a:effectLst>
         </p:spPr>
+        <p:txBody>
+          <a:bodyPr/>
+          <a:lstStyle/>
+          <a:p>
+            <a:endParaRPr lang="fr-FR"/>
+          </a:p>
+        </p:txBody>
       </p:sp>
       <p:sp>
         <p:nvSpPr>
@@ -7203,7 +6945,7 @@
           <a:bodyPr wrap="square" rtlCol="0" anchor="ctr"/>
           <a:lstStyle/>
           <a:p>
-            <a:pPr algn="ctr" indent="0" marL="0">
+            <a:pPr marL="0" indent="0" algn="ctr">
               <a:buNone/>
             </a:pPr>
             <a:r>
@@ -7239,7 +6981,7 @@
           <a:bodyPr wrap="square" rtlCol="0" anchor="ctr"/>
           <a:lstStyle/>
           <a:p>
-            <a:pPr algn="ctr" indent="0" marL="0">
+            <a:pPr marL="0" indent="0" algn="ctr">
               <a:buNone/>
             </a:pPr>
             <a:r>
@@ -7253,7 +6995,7 @@
             <a:endParaRPr lang="en-US" sz="1000" dirty="0"/>
           </a:p>
           <a:p>
-            <a:pPr algn="ctr" indent="0" marL="0">
+            <a:pPr marL="0" indent="0" algn="ctr">
               <a:buNone/>
             </a:pPr>
             <a:r>
@@ -7292,6 +7034,13 @@
             <a:prstDash val="solid"/>
           </a:ln>
         </p:spPr>
+        <p:txBody>
+          <a:bodyPr/>
+          <a:lstStyle/>
+          <a:p>
+            <a:endParaRPr lang="fr-FR"/>
+          </a:p>
+        </p:txBody>
       </p:sp>
       <p:sp>
         <p:nvSpPr>
@@ -7301,7 +7050,7 @@
         </p:nvSpPr>
         <p:spPr>
           <a:xfrm>
-            <a:off x="6565392" y="1554480"/>
+            <a:off x="6652260" y="1581912"/>
             <a:ext cx="182880" cy="365760"/>
           </a:xfrm>
           <a:prstGeom prst="rect">
@@ -7314,7 +7063,7 @@
           <a:bodyPr wrap="square" rtlCol="0" anchor="ctr"/>
           <a:lstStyle/>
           <a:p>
-            <a:pPr algn="ctr" indent="0" marL="0">
+            <a:pPr marL="0" indent="0" algn="ctr">
               <a:buNone/>
             </a:pPr>
             <a:r>
@@ -7353,13 +7102,20 @@
             <a:prstDash val="solid"/>
           </a:ln>
           <a:effectLst>
-            <a:outerShdw sx="100000" sy="100000" kx="0" ky="0" algn="bl" rotWithShape="0" blurRad="101600" dist="38100" dir="8100000">
+            <a:outerShdw blurRad="101600" dist="38100" dir="8100000" algn="bl" rotWithShape="0">
               <a:srgbClr val="000000">
                 <a:alpha val="12000"/>
               </a:srgbClr>
             </a:outerShdw>
           </a:effectLst>
         </p:spPr>
+        <p:txBody>
+          <a:bodyPr/>
+          <a:lstStyle/>
+          <a:p>
+            <a:endParaRPr lang="fr-FR"/>
+          </a:p>
+        </p:txBody>
       </p:sp>
       <p:sp>
         <p:nvSpPr>
@@ -7382,7 +7138,7 @@
           <a:bodyPr wrap="square" rtlCol="0" anchor="ctr"/>
           <a:lstStyle/>
           <a:p>
-            <a:pPr algn="ctr" indent="0" marL="0">
+            <a:pPr marL="0" indent="0" algn="ctr">
               <a:buNone/>
             </a:pPr>
             <a:r>
@@ -7418,7 +7174,7 @@
           <a:bodyPr wrap="square" rtlCol="0" anchor="ctr"/>
           <a:lstStyle/>
           <a:p>
-            <a:pPr algn="ctr" indent="0" marL="0">
+            <a:pPr marL="0" indent="0" algn="ctr">
               <a:buNone/>
             </a:pPr>
             <a:r>
@@ -7432,7 +7188,7 @@
             <a:endParaRPr lang="en-US" sz="1000" dirty="0"/>
           </a:p>
           <a:p>
-            <a:pPr algn="ctr" indent="0" marL="0">
+            <a:pPr marL="0" indent="0" algn="ctr">
               <a:buNone/>
             </a:pPr>
             <a:r>
@@ -7471,13 +7227,20 @@
             <a:prstDash val="solid"/>
           </a:ln>
           <a:effectLst>
-            <a:outerShdw sx="100000" sy="100000" kx="0" ky="0" algn="bl" rotWithShape="0" blurRad="101600" dist="38100" dir="8100000">
+            <a:outerShdw blurRad="101600" dist="38100" dir="8100000" algn="bl" rotWithShape="0">
               <a:srgbClr val="000000">
                 <a:alpha val="12000"/>
               </a:srgbClr>
             </a:outerShdw>
           </a:effectLst>
         </p:spPr>
+        <p:txBody>
+          <a:bodyPr/>
+          <a:lstStyle/>
+          <a:p>
+            <a:endParaRPr lang="fr-FR"/>
+          </a:p>
+        </p:txBody>
       </p:sp>
       <p:sp>
         <p:nvSpPr>
@@ -7503,6 +7266,13 @@
             <a:prstDash val="solid"/>
           </a:ln>
         </p:spPr>
+        <p:txBody>
+          <a:bodyPr/>
+          <a:lstStyle/>
+          <a:p>
+            <a:endParaRPr lang="fr-FR"/>
+          </a:p>
+        </p:txBody>
       </p:sp>
       <p:sp>
         <p:nvSpPr>
@@ -7525,7 +7295,7 @@
           <a:bodyPr wrap="square" lIns="0" tIns="0" rIns="0" bIns="0" rtlCol="0" anchor="ctr"/>
           <a:lstStyle/>
           <a:p>
-            <a:pPr indent="0" marL="0">
+            <a:pPr marL="0" indent="0">
               <a:buNone/>
             </a:pPr>
             <a:r>
@@ -7613,67 +7383,6 @@
               <a:t>Le build Docker échoue</a:t>
             </a:r>
             <a:endParaRPr lang="en-US" sz="1200" dirty="0"/>
-          </a:p>
-        </p:txBody>
-      </p:sp>
-      <p:sp>
-        <p:nvSpPr>
-          <p:cNvPr id="28" name="Shape 26"/>
-          <p:cNvSpPr/>
-          <p:nvPr/>
-        </p:nvSpPr>
-        <p:spPr>
-          <a:xfrm>
-            <a:off x="0" y="4800600"/>
-            <a:ext cx="9144000" cy="342900"/>
-          </a:xfrm>
-          <a:prstGeom prst="rect">
-            <a:avLst/>
-          </a:prstGeom>
-          <a:solidFill>
-            <a:srgbClr val="1A2B4A"/>
-          </a:solidFill>
-          <a:ln w="12700">
-            <a:solidFill>
-              <a:srgbClr val="1A2B4A"/>
-            </a:solidFill>
-            <a:prstDash val="solid"/>
-          </a:ln>
-        </p:spPr>
-      </p:sp>
-      <p:sp>
-        <p:nvSpPr>
-          <p:cNvPr id="29" name="Text 27"/>
-          <p:cNvSpPr/>
-          <p:nvPr/>
-        </p:nvSpPr>
-        <p:spPr>
-          <a:xfrm>
-            <a:off x="365760" y="4800600"/>
-            <a:ext cx="8412480" cy="342900"/>
-          </a:xfrm>
-          <a:prstGeom prst="rect">
-            <a:avLst/>
-          </a:prstGeom>
-          <a:noFill/>
-          <a:ln/>
-        </p:spPr>
-        <p:txBody>
-          <a:bodyPr wrap="square" rtlCol="0" anchor="ctr"/>
-          <a:lstStyle/>
-          <a:p>
-            <a:pPr indent="0" marL="0">
-              <a:buNone/>
-            </a:pPr>
-            <a:r>
-              <a:rPr lang="en-US" sz="1000" dirty="0">
-                <a:solidFill>
-                  <a:srgbClr val="94A3B8"/>
-                </a:solidFill>
-              </a:rPr>
-              <a:t>TP5 – Password Change &amp; Docker  ·  D. Samfat</a:t>
-            </a:r>
-            <a:endParaRPr lang="en-US" sz="1000" dirty="0"/>
           </a:p>
         </p:txBody>
       </p:sp>
@@ -7693,6 +7402,7 @@
         <a:solidFill>
           <a:srgbClr val="F4F7F9"/>
         </a:solidFill>
+        <a:effectLst/>
       </p:bgPr>
     </p:bg>
     <p:spTree>
@@ -7733,6 +7443,13 @@
             <a:prstDash val="solid"/>
           </a:ln>
         </p:spPr>
+        <p:txBody>
+          <a:bodyPr/>
+          <a:lstStyle/>
+          <a:p>
+            <a:endParaRPr lang="fr-FR"/>
+          </a:p>
+        </p:txBody>
       </p:sp>
       <p:sp>
         <p:nvSpPr>
@@ -7758,6 +7475,13 @@
             <a:prstDash val="solid"/>
           </a:ln>
         </p:spPr>
+        <p:txBody>
+          <a:bodyPr/>
+          <a:lstStyle/>
+          <a:p>
+            <a:endParaRPr lang="fr-FR"/>
+          </a:p>
+        </p:txBody>
       </p:sp>
       <p:sp>
         <p:nvSpPr>
@@ -7780,7 +7504,7 @@
           <a:bodyPr wrap="square" rtlCol="0" anchor="ctr"/>
           <a:lstStyle/>
           <a:p>
-            <a:pPr indent="0" marL="0">
+            <a:pPr marL="0" indent="0">
               <a:buNone/>
             </a:pPr>
             <a:r>
@@ -7816,7 +7540,7 @@
           <a:bodyPr wrap="square" rtlCol="0" anchor="ctr"/>
           <a:lstStyle/>
           <a:p>
-            <a:pPr algn="r" indent="0" marL="0">
+            <a:pPr marL="0" indent="0" algn="r">
               <a:buNone/>
             </a:pPr>
             <a:r>
@@ -7855,6 +7579,13 @@
             <a:prstDash val="solid"/>
           </a:ln>
         </p:spPr>
+        <p:txBody>
+          <a:bodyPr/>
+          <a:lstStyle/>
+          <a:p>
+            <a:endParaRPr lang="fr-FR"/>
+          </a:p>
+        </p:txBody>
       </p:sp>
       <p:sp>
         <p:nvSpPr>
@@ -7880,6 +7611,13 @@
             <a:prstDash val="solid"/>
           </a:ln>
         </p:spPr>
+        <p:txBody>
+          <a:bodyPr/>
+          <a:lstStyle/>
+          <a:p>
+            <a:endParaRPr lang="fr-FR"/>
+          </a:p>
+        </p:txBody>
       </p:sp>
       <p:sp>
         <p:nvSpPr>
@@ -7902,7 +7640,7 @@
           <a:bodyPr wrap="square" rtlCol="0" anchor="ctr"/>
           <a:lstStyle/>
           <a:p>
-            <a:pPr indent="0" marL="0">
+            <a:pPr marL="0" indent="0">
               <a:buNone/>
             </a:pPr>
             <a:r>
@@ -7941,6 +7679,13 @@
             <a:prstDash val="solid"/>
           </a:ln>
         </p:spPr>
+        <p:txBody>
+          <a:bodyPr/>
+          <a:lstStyle/>
+          <a:p>
+            <a:endParaRPr lang="fr-FR"/>
+          </a:p>
+        </p:txBody>
       </p:sp>
       <p:sp>
         <p:nvSpPr>
@@ -7963,7 +7708,7 @@
           <a:bodyPr wrap="square" lIns="0" tIns="0" rIns="0" bIns="0" rtlCol="0" anchor="ctr"/>
           <a:lstStyle/>
           <a:p>
-            <a:pPr algn="ctr" indent="0" marL="0">
+            <a:pPr marL="0" indent="0" algn="ctr">
               <a:buNone/>
             </a:pPr>
             <a:r>
@@ -8005,6 +7750,13 @@
             <a:prstDash val="solid"/>
           </a:ln>
         </p:spPr>
+        <p:txBody>
+          <a:bodyPr/>
+          <a:lstStyle/>
+          <a:p>
+            <a:endParaRPr lang="fr-FR"/>
+          </a:p>
+        </p:txBody>
       </p:sp>
       <p:sp>
         <p:nvSpPr>
@@ -8030,6 +7782,13 @@
             <a:prstDash val="solid"/>
           </a:ln>
         </p:spPr>
+        <p:txBody>
+          <a:bodyPr/>
+          <a:lstStyle/>
+          <a:p>
+            <a:endParaRPr lang="fr-FR"/>
+          </a:p>
+        </p:txBody>
       </p:sp>
       <p:sp>
         <p:nvSpPr>
@@ -8052,7 +7811,7 @@
           <a:bodyPr wrap="square" rtlCol="0" anchor="ctr"/>
           <a:lstStyle/>
           <a:p>
-            <a:pPr indent="0" marL="0">
+            <a:pPr marL="0" indent="0">
               <a:buNone/>
             </a:pPr>
             <a:r>
@@ -8091,6 +7850,13 @@
             <a:prstDash val="solid"/>
           </a:ln>
         </p:spPr>
+        <p:txBody>
+          <a:bodyPr/>
+          <a:lstStyle/>
+          <a:p>
+            <a:endParaRPr lang="fr-FR"/>
+          </a:p>
+        </p:txBody>
       </p:sp>
       <p:sp>
         <p:nvSpPr>
@@ -8113,7 +7879,7 @@
           <a:bodyPr wrap="square" lIns="0" tIns="0" rIns="0" bIns="0" rtlCol="0" anchor="ctr"/>
           <a:lstStyle/>
           <a:p>
-            <a:pPr algn="ctr" indent="0" marL="0">
+            <a:pPr marL="0" indent="0" algn="ctr">
               <a:buNone/>
             </a:pPr>
             <a:r>
@@ -8155,6 +7921,13 @@
             <a:prstDash val="solid"/>
           </a:ln>
         </p:spPr>
+        <p:txBody>
+          <a:bodyPr/>
+          <a:lstStyle/>
+          <a:p>
+            <a:endParaRPr lang="fr-FR"/>
+          </a:p>
+        </p:txBody>
       </p:sp>
       <p:sp>
         <p:nvSpPr>
@@ -8180,6 +7953,13 @@
             <a:prstDash val="solid"/>
           </a:ln>
         </p:spPr>
+        <p:txBody>
+          <a:bodyPr/>
+          <a:lstStyle/>
+          <a:p>
+            <a:endParaRPr lang="fr-FR"/>
+          </a:p>
+        </p:txBody>
       </p:sp>
       <p:sp>
         <p:nvSpPr>
@@ -8202,7 +7982,7 @@
           <a:bodyPr wrap="square" rtlCol="0" anchor="ctr"/>
           <a:lstStyle/>
           <a:p>
-            <a:pPr indent="0" marL="0">
+            <a:pPr marL="0" indent="0">
               <a:buNone/>
             </a:pPr>
             <a:r>
@@ -8241,6 +8021,13 @@
             <a:prstDash val="solid"/>
           </a:ln>
         </p:spPr>
+        <p:txBody>
+          <a:bodyPr/>
+          <a:lstStyle/>
+          <a:p>
+            <a:endParaRPr lang="fr-FR"/>
+          </a:p>
+        </p:txBody>
       </p:sp>
       <p:sp>
         <p:nvSpPr>
@@ -8263,7 +8050,7 @@
           <a:bodyPr wrap="square" lIns="0" tIns="0" rIns="0" bIns="0" rtlCol="0" anchor="ctr"/>
           <a:lstStyle/>
           <a:p>
-            <a:pPr algn="ctr" indent="0" marL="0">
+            <a:pPr marL="0" indent="0" algn="ctr">
               <a:buNone/>
             </a:pPr>
             <a:r>
@@ -8305,6 +8092,13 @@
             <a:prstDash val="solid"/>
           </a:ln>
         </p:spPr>
+        <p:txBody>
+          <a:bodyPr/>
+          <a:lstStyle/>
+          <a:p>
+            <a:endParaRPr lang="fr-FR"/>
+          </a:p>
+        </p:txBody>
       </p:sp>
       <p:sp>
         <p:nvSpPr>
@@ -8330,6 +8124,13 @@
             <a:prstDash val="solid"/>
           </a:ln>
         </p:spPr>
+        <p:txBody>
+          <a:bodyPr/>
+          <a:lstStyle/>
+          <a:p>
+            <a:endParaRPr lang="fr-FR"/>
+          </a:p>
+        </p:txBody>
       </p:sp>
       <p:sp>
         <p:nvSpPr>
@@ -8352,7 +8153,7 @@
           <a:bodyPr wrap="square" rtlCol="0" anchor="ctr"/>
           <a:lstStyle/>
           <a:p>
-            <a:pPr indent="0" marL="0">
+            <a:pPr marL="0" indent="0">
               <a:buNone/>
             </a:pPr>
             <a:r>
@@ -8391,6 +8192,13 @@
             <a:prstDash val="solid"/>
           </a:ln>
         </p:spPr>
+        <p:txBody>
+          <a:bodyPr/>
+          <a:lstStyle/>
+          <a:p>
+            <a:endParaRPr lang="fr-FR"/>
+          </a:p>
+        </p:txBody>
       </p:sp>
       <p:sp>
         <p:nvSpPr>
@@ -8413,7 +8221,7 @@
           <a:bodyPr wrap="square" lIns="0" tIns="0" rIns="0" bIns="0" rtlCol="0" anchor="ctr"/>
           <a:lstStyle/>
           <a:p>
-            <a:pPr algn="ctr" indent="0" marL="0">
+            <a:pPr marL="0" indent="0" algn="ctr">
               <a:buNone/>
             </a:pPr>
             <a:r>
@@ -8455,6 +8263,13 @@
             <a:prstDash val="solid"/>
           </a:ln>
         </p:spPr>
+        <p:txBody>
+          <a:bodyPr/>
+          <a:lstStyle/>
+          <a:p>
+            <a:endParaRPr lang="fr-FR"/>
+          </a:p>
+        </p:txBody>
       </p:sp>
       <p:sp>
         <p:nvSpPr>
@@ -8480,6 +8295,13 @@
             <a:prstDash val="solid"/>
           </a:ln>
         </p:spPr>
+        <p:txBody>
+          <a:bodyPr/>
+          <a:lstStyle/>
+          <a:p>
+            <a:endParaRPr lang="fr-FR"/>
+          </a:p>
+        </p:txBody>
       </p:sp>
       <p:sp>
         <p:nvSpPr>
@@ -8502,7 +8324,7 @@
           <a:bodyPr wrap="square" rtlCol="0" anchor="ctr"/>
           <a:lstStyle/>
           <a:p>
-            <a:pPr indent="0" marL="0">
+            <a:pPr marL="0" indent="0">
               <a:buNone/>
             </a:pPr>
             <a:r>
@@ -8541,6 +8363,13 @@
             <a:prstDash val="solid"/>
           </a:ln>
         </p:spPr>
+        <p:txBody>
+          <a:bodyPr/>
+          <a:lstStyle/>
+          <a:p>
+            <a:endParaRPr lang="fr-FR"/>
+          </a:p>
+        </p:txBody>
       </p:sp>
       <p:sp>
         <p:nvSpPr>
@@ -8563,7 +8392,7 @@
           <a:bodyPr wrap="square" lIns="0" tIns="0" rIns="0" bIns="0" rtlCol="0" anchor="ctr"/>
           <a:lstStyle/>
           <a:p>
-            <a:pPr algn="ctr" indent="0" marL="0">
+            <a:pPr marL="0" indent="0" algn="ctr">
               <a:buNone/>
             </a:pPr>
             <a:r>
@@ -8605,6 +8434,13 @@
             <a:prstDash val="solid"/>
           </a:ln>
         </p:spPr>
+        <p:txBody>
+          <a:bodyPr/>
+          <a:lstStyle/>
+          <a:p>
+            <a:endParaRPr lang="fr-FR"/>
+          </a:p>
+        </p:txBody>
       </p:sp>
       <p:sp>
         <p:nvSpPr>
@@ -8627,7 +8463,7 @@
           <a:bodyPr wrap="square" rtlCol="0" anchor="ctr"/>
           <a:lstStyle/>
           <a:p>
-            <a:pPr indent="0" marL="0">
+            <a:pPr marL="0" indent="0">
               <a:buNone/>
             </a:pPr>
             <a:r>
@@ -8666,6 +8502,13 @@
             <a:prstDash val="solid"/>
           </a:ln>
         </p:spPr>
+        <p:txBody>
+          <a:bodyPr/>
+          <a:lstStyle/>
+          <a:p>
+            <a:endParaRPr lang="fr-FR"/>
+          </a:p>
+        </p:txBody>
       </p:sp>
       <p:sp>
         <p:nvSpPr>
@@ -8688,7 +8531,7 @@
           <a:bodyPr wrap="square" lIns="0" tIns="0" rIns="0" bIns="0" rtlCol="0" anchor="ctr"/>
           <a:lstStyle/>
           <a:p>
-            <a:pPr algn="ctr" indent="0" marL="0">
+            <a:pPr marL="0" indent="0" algn="ctr">
               <a:buNone/>
             </a:pPr>
             <a:r>
@@ -8701,67 +8544,6 @@
                 <a:cs typeface="Consolas" pitchFamily="34" charset="-120"/>
               </a:rPr>
               <a:t>git push origin main --tags</a:t>
-            </a:r>
-            <a:endParaRPr lang="en-US" sz="1000" dirty="0"/>
-          </a:p>
-        </p:txBody>
-      </p:sp>
-      <p:sp>
-        <p:nvSpPr>
-          <p:cNvPr id="35" name="Shape 33"/>
-          <p:cNvSpPr/>
-          <p:nvPr/>
-        </p:nvSpPr>
-        <p:spPr>
-          <a:xfrm>
-            <a:off x="0" y="4800600"/>
-            <a:ext cx="9144000" cy="342900"/>
-          </a:xfrm>
-          <a:prstGeom prst="rect">
-            <a:avLst/>
-          </a:prstGeom>
-          <a:solidFill>
-            <a:srgbClr val="1A2B4A"/>
-          </a:solidFill>
-          <a:ln w="12700">
-            <a:solidFill>
-              <a:srgbClr val="1A2B4A"/>
-            </a:solidFill>
-            <a:prstDash val="solid"/>
-          </a:ln>
-        </p:spPr>
-      </p:sp>
-      <p:sp>
-        <p:nvSpPr>
-          <p:cNvPr id="36" name="Text 34"/>
-          <p:cNvSpPr/>
-          <p:nvPr/>
-        </p:nvSpPr>
-        <p:spPr>
-          <a:xfrm>
-            <a:off x="365760" y="4800600"/>
-            <a:ext cx="8412480" cy="342900"/>
-          </a:xfrm>
-          <a:prstGeom prst="rect">
-            <a:avLst/>
-          </a:prstGeom>
-          <a:noFill/>
-          <a:ln/>
-        </p:spPr>
-        <p:txBody>
-          <a:bodyPr wrap="square" rtlCol="0" anchor="ctr"/>
-          <a:lstStyle/>
-          <a:p>
-            <a:pPr indent="0" marL="0">
-              <a:buNone/>
-            </a:pPr>
-            <a:r>
-              <a:rPr lang="en-US" sz="1000" dirty="0">
-                <a:solidFill>
-                  <a:srgbClr val="94A3B8"/>
-                </a:solidFill>
-              </a:rPr>
-              <a:t>TP5 – Password Change &amp; Docker  ·  D. Samfat</a:t>
             </a:r>
             <a:endParaRPr lang="en-US" sz="1000" dirty="0"/>
           </a:p>
@@ -8783,6 +8565,7 @@
         <a:solidFill>
           <a:srgbClr val="1A2B4A"/>
         </a:solidFill>
+        <a:effectLst/>
       </p:bgPr>
     </p:bg>
     <p:spTree>
@@ -8823,35 +8606,13 @@
             <a:prstDash val="solid"/>
           </a:ln>
         </p:spPr>
-      </p:sp>
-      <p:sp>
-        <p:nvSpPr>
-          <p:cNvPr id="3" name="Shape 1"/>
-          <p:cNvSpPr/>
-          <p:nvPr/>
-        </p:nvSpPr>
-        <p:spPr>
-          <a:xfrm>
-            <a:off x="6400800" y="3200400"/>
-            <a:ext cx="3200400" cy="3200400"/>
-          </a:xfrm>
-          <a:prstGeom prst="ellipse">
-            <a:avLst/>
-          </a:prstGeom>
-          <a:solidFill>
-            <a:srgbClr val="0D9488">
-              <a:alpha val="15000"/>
-            </a:srgbClr>
-          </a:solidFill>
-          <a:ln w="12700">
-            <a:solidFill>
-              <a:srgbClr val="0D9488">
-                <a:alpha val="15000"/>
-              </a:srgbClr>
-            </a:solidFill>
-            <a:prstDash val="solid"/>
-          </a:ln>
-        </p:spPr>
+        <p:txBody>
+          <a:bodyPr/>
+          <a:lstStyle/>
+          <a:p>
+            <a:endParaRPr lang="fr-FR"/>
+          </a:p>
+        </p:txBody>
       </p:sp>
       <p:sp>
         <p:nvSpPr>
@@ -8874,7 +8635,7 @@
           <a:bodyPr wrap="square" rtlCol="0" anchor="ctr"/>
           <a:lstStyle/>
           <a:p>
-            <a:pPr indent="0" marL="0">
+            <a:pPr marL="0" indent="0">
               <a:buNone/>
             </a:pPr>
             <a:r>
@@ -8917,6 +8678,13 @@
             <a:prstDash val="solid"/>
           </a:ln>
         </p:spPr>
+        <p:txBody>
+          <a:bodyPr/>
+          <a:lstStyle/>
+          <a:p>
+            <a:endParaRPr lang="fr-FR"/>
+          </a:p>
+        </p:txBody>
       </p:sp>
       <p:sp>
         <p:nvSpPr>
@@ -8939,7 +8707,7 @@
           <a:bodyPr wrap="square" rtlCol="0" anchor="ctr"/>
           <a:lstStyle/>
           <a:p>
-            <a:pPr algn="ctr" indent="0" marL="0">
+            <a:pPr marL="0" indent="0" algn="ctr">
               <a:buNone/>
             </a:pPr>
             <a:r>
@@ -8975,7 +8743,7 @@
           <a:bodyPr wrap="square" rtlCol="0" anchor="ctr"/>
           <a:lstStyle/>
           <a:p>
-            <a:pPr indent="0" marL="0">
+            <a:pPr marL="0" indent="0">
               <a:buNone/>
             </a:pPr>
             <a:r>
@@ -9011,7 +8779,7 @@
           <a:bodyPr wrap="square" rtlCol="0" anchor="ctr"/>
           <a:lstStyle/>
           <a:p>
-            <a:pPr indent="0" marL="0">
+            <a:pPr marL="0" indent="0">
               <a:buNone/>
             </a:pPr>
             <a:r>
@@ -9047,7 +8815,7 @@
           <a:bodyPr wrap="square" rtlCol="0" anchor="ctr"/>
           <a:lstStyle/>
           <a:p>
-            <a:pPr algn="ctr" indent="0" marL="0">
+            <a:pPr marL="0" indent="0" algn="ctr">
               <a:buNone/>
             </a:pPr>
             <a:r>
@@ -9083,7 +8851,7 @@
           <a:bodyPr wrap="square" rtlCol="0" anchor="ctr"/>
           <a:lstStyle/>
           <a:p>
-            <a:pPr indent="0" marL="0">
+            <a:pPr marL="0" indent="0">
               <a:buNone/>
             </a:pPr>
             <a:r>
@@ -9119,7 +8887,7 @@
           <a:bodyPr wrap="square" rtlCol="0" anchor="ctr"/>
           <a:lstStyle/>
           <a:p>
-            <a:pPr indent="0" marL="0">
+            <a:pPr marL="0" indent="0">
               <a:buNone/>
             </a:pPr>
             <a:r>
@@ -9155,7 +8923,7 @@
           <a:bodyPr wrap="square" rtlCol="0" anchor="ctr"/>
           <a:lstStyle/>
           <a:p>
-            <a:pPr algn="ctr" indent="0" marL="0">
+            <a:pPr marL="0" indent="0" algn="ctr">
               <a:buNone/>
             </a:pPr>
             <a:r>
@@ -9191,7 +8959,7 @@
           <a:bodyPr wrap="square" rtlCol="0" anchor="ctr"/>
           <a:lstStyle/>
           <a:p>
-            <a:pPr indent="0" marL="0">
+            <a:pPr marL="0" indent="0">
               <a:buNone/>
             </a:pPr>
             <a:r>
@@ -9227,7 +8995,7 @@
           <a:bodyPr wrap="square" rtlCol="0" anchor="ctr"/>
           <a:lstStyle/>
           <a:p>
-            <a:pPr indent="0" marL="0">
+            <a:pPr marL="0" indent="0">
               <a:buNone/>
             </a:pPr>
             <a:r>
@@ -9263,7 +9031,7 @@
           <a:bodyPr wrap="square" rtlCol="0" anchor="ctr"/>
           <a:lstStyle/>
           <a:p>
-            <a:pPr algn="ctr" indent="0" marL="0">
+            <a:pPr marL="0" indent="0" algn="ctr">
               <a:buNone/>
             </a:pPr>
             <a:r>
@@ -9299,7 +9067,7 @@
           <a:bodyPr wrap="square" rtlCol="0" anchor="ctr"/>
           <a:lstStyle/>
           <a:p>
-            <a:pPr indent="0" marL="0">
+            <a:pPr marL="0" indent="0">
               <a:buNone/>
             </a:pPr>
             <a:r>
@@ -9335,7 +9103,7 @@
           <a:bodyPr wrap="square" rtlCol="0" anchor="ctr"/>
           <a:lstStyle/>
           <a:p>
-            <a:pPr indent="0" marL="0">
+            <a:pPr marL="0" indent="0">
               <a:buNone/>
             </a:pPr>
             <a:r>
@@ -9347,67 +9115,6 @@
               <a:t>Maintenir tests, SonarCloud et sécurité tout au long des évolutions</a:t>
             </a:r>
             <a:endParaRPr lang="en-US" sz="1150" dirty="0"/>
-          </a:p>
-        </p:txBody>
-      </p:sp>
-      <p:sp>
-        <p:nvSpPr>
-          <p:cNvPr id="18" name="Shape 16"/>
-          <p:cNvSpPr/>
-          <p:nvPr/>
-        </p:nvSpPr>
-        <p:spPr>
-          <a:xfrm>
-            <a:off x="0" y="4800600"/>
-            <a:ext cx="9144000" cy="342900"/>
-          </a:xfrm>
-          <a:prstGeom prst="rect">
-            <a:avLst/>
-          </a:prstGeom>
-          <a:solidFill>
-            <a:srgbClr val="0F1928"/>
-          </a:solidFill>
-          <a:ln w="12700">
-            <a:solidFill>
-              <a:srgbClr val="0F1928"/>
-            </a:solidFill>
-            <a:prstDash val="solid"/>
-          </a:ln>
-        </p:spPr>
-      </p:sp>
-      <p:sp>
-        <p:nvSpPr>
-          <p:cNvPr id="19" name="Text 17"/>
-          <p:cNvSpPr/>
-          <p:nvPr/>
-        </p:nvSpPr>
-        <p:spPr>
-          <a:xfrm>
-            <a:off x="365760" y="4800600"/>
-            <a:ext cx="8412480" cy="342900"/>
-          </a:xfrm>
-          <a:prstGeom prst="rect">
-            <a:avLst/>
-          </a:prstGeom>
-          <a:noFill/>
-          <a:ln/>
-        </p:spPr>
-        <p:txBody>
-          <a:bodyPr wrap="square" rtlCol="0" anchor="ctr"/>
-          <a:lstStyle/>
-          <a:p>
-            <a:pPr indent="0" marL="0">
-              <a:buNone/>
-            </a:pPr>
-            <a:r>
-              <a:rPr lang="en-US" sz="1000" dirty="0">
-                <a:solidFill>
-                  <a:srgbClr val="94A3B8"/>
-                </a:solidFill>
-              </a:rPr>
-              <a:t>TP5 – Password Change &amp; Docker  ·  D. Samfat</a:t>
-            </a:r>
-            <a:endParaRPr lang="en-US" sz="1000" dirty="0"/>
           </a:p>
         </p:txBody>
       </p:sp>
@@ -9712,4 +9419,319 @@
     </a:ext>
   </a:extLst>
 </a:theme>
+</file>
+
+<file path=ppt/theme/theme2.xml><?xml version="1.0" encoding="utf-8"?>
+<a:theme xmlns:a="http://schemas.openxmlformats.org/drawingml/2006/main" name="Thème Office">
+  <a:themeElements>
+    <a:clrScheme name="Office">
+      <a:dk1>
+        <a:sysClr val="windowText" lastClr="000000"/>
+      </a:dk1>
+      <a:lt1>
+        <a:sysClr val="window" lastClr="FFFFFF"/>
+      </a:lt1>
+      <a:dk2>
+        <a:srgbClr val="0E2841"/>
+      </a:dk2>
+      <a:lt2>
+        <a:srgbClr val="E8E8E8"/>
+      </a:lt2>
+      <a:accent1>
+        <a:srgbClr val="156082"/>
+      </a:accent1>
+      <a:accent2>
+        <a:srgbClr val="E97132"/>
+      </a:accent2>
+      <a:accent3>
+        <a:srgbClr val="196B24"/>
+      </a:accent3>
+      <a:accent4>
+        <a:srgbClr val="0F9ED5"/>
+      </a:accent4>
+      <a:accent5>
+        <a:srgbClr val="A02B93"/>
+      </a:accent5>
+      <a:accent6>
+        <a:srgbClr val="4EA72E"/>
+      </a:accent6>
+      <a:hlink>
+        <a:srgbClr val="467886"/>
+      </a:hlink>
+      <a:folHlink>
+        <a:srgbClr val="96607D"/>
+      </a:folHlink>
+    </a:clrScheme>
+    <a:fontScheme name="Office">
+      <a:majorFont>
+        <a:latin typeface="Aptos Display" panose="02110004020202020204"/>
+        <a:ea typeface=""/>
+        <a:cs typeface=""/>
+        <a:font script="Jpan" typeface="游ゴシック Light"/>
+        <a:font script="Hang" typeface="맑은 고딕"/>
+        <a:font script="Hans" typeface="等线 Light"/>
+        <a:font script="Hant" typeface="新細明體"/>
+        <a:font script="Arab" typeface="Times New Roman"/>
+        <a:font script="Hebr" typeface="Times New Roman"/>
+        <a:font script="Thai" typeface="Angsana New"/>
+        <a:font script="Ethi" typeface="Nyala"/>
+        <a:font script="Beng" typeface="Vrinda"/>
+        <a:font script="Gujr" typeface="Shruti"/>
+        <a:font script="Khmr" typeface="MoolBoran"/>
+        <a:font script="Knda" typeface="Tunga"/>
+        <a:font script="Guru" typeface="Raavi"/>
+        <a:font script="Cans" typeface="Euphemia"/>
+        <a:font script="Cher" typeface="Plantagenet Cherokee"/>
+        <a:font script="Yiii" typeface="Microsoft Yi Baiti"/>
+        <a:font script="Tibt" typeface="Microsoft Himalaya"/>
+        <a:font script="Thaa" typeface="MV Boli"/>
+        <a:font script="Deva" typeface="Mangal"/>
+        <a:font script="Telu" typeface="Gautami"/>
+        <a:font script="Taml" typeface="Latha"/>
+        <a:font script="Syrc" typeface="Estrangelo Edessa"/>
+        <a:font script="Orya" typeface="Kalinga"/>
+        <a:font script="Mlym" typeface="Kartika"/>
+        <a:font script="Laoo" typeface="DokChampa"/>
+        <a:font script="Sinh" typeface="Iskoola Pota"/>
+        <a:font script="Mong" typeface="Mongolian Baiti"/>
+        <a:font script="Viet" typeface="Times New Roman"/>
+        <a:font script="Uigh" typeface="Microsoft Uighur"/>
+        <a:font script="Geor" typeface="Sylfaen"/>
+        <a:font script="Armn" typeface="Arial"/>
+        <a:font script="Bugi" typeface="Leelawadee UI"/>
+        <a:font script="Bopo" typeface="Microsoft JhengHei"/>
+        <a:font script="Java" typeface="Javanese Text"/>
+        <a:font script="Lisu" typeface="Segoe UI"/>
+        <a:font script="Mymr" typeface="Myanmar Text"/>
+        <a:font script="Nkoo" typeface="Ebrima"/>
+        <a:font script="Olck" typeface="Nirmala UI"/>
+        <a:font script="Osma" typeface="Ebrima"/>
+        <a:font script="Phag" typeface="Phagspa"/>
+        <a:font script="Syrn" typeface="Estrangelo Edessa"/>
+        <a:font script="Syrj" typeface="Estrangelo Edessa"/>
+        <a:font script="Syre" typeface="Estrangelo Edessa"/>
+        <a:font script="Sora" typeface="Nirmala UI"/>
+        <a:font script="Tale" typeface="Microsoft Tai Le"/>
+        <a:font script="Talu" typeface="Microsoft New Tai Lue"/>
+        <a:font script="Tfng" typeface="Ebrima"/>
+      </a:majorFont>
+      <a:minorFont>
+        <a:latin typeface="Aptos" panose="02110004020202020204"/>
+        <a:ea typeface=""/>
+        <a:cs typeface=""/>
+        <a:font script="Jpan" typeface="游ゴシック"/>
+        <a:font script="Hang" typeface="맑은 고딕"/>
+        <a:font script="Hans" typeface="等线"/>
+        <a:font script="Hant" typeface="新細明體"/>
+        <a:font script="Arab" typeface="Arial"/>
+        <a:font script="Hebr" typeface="Arial"/>
+        <a:font script="Thai" typeface="Cordia New"/>
+        <a:font script="Ethi" typeface="Nyala"/>
+        <a:font script="Beng" typeface="Vrinda"/>
+        <a:font script="Gujr" typeface="Shruti"/>
+        <a:font script="Khmr" typeface="DaunPenh"/>
+        <a:font script="Knda" typeface="Tunga"/>
+        <a:font script="Guru" typeface="Raavi"/>
+        <a:font script="Cans" typeface="Euphemia"/>
+        <a:font script="Cher" typeface="Plantagenet Cherokee"/>
+        <a:font script="Yiii" typeface="Microsoft Yi Baiti"/>
+        <a:font script="Tibt" typeface="Microsoft Himalaya"/>
+        <a:font script="Thaa" typeface="MV Boli"/>
+        <a:font script="Deva" typeface="Mangal"/>
+        <a:font script="Telu" typeface="Gautami"/>
+        <a:font script="Taml" typeface="Latha"/>
+        <a:font script="Syrc" typeface="Estrangelo Edessa"/>
+        <a:font script="Orya" typeface="Kalinga"/>
+        <a:font script="Mlym" typeface="Kartika"/>
+        <a:font script="Laoo" typeface="DokChampa"/>
+        <a:font script="Sinh" typeface="Iskoola Pota"/>
+        <a:font script="Mong" typeface="Mongolian Baiti"/>
+        <a:font script="Viet" typeface="Arial"/>
+        <a:font script="Uigh" typeface="Microsoft Uighur"/>
+        <a:font script="Geor" typeface="Sylfaen"/>
+        <a:font script="Armn" typeface="Arial"/>
+        <a:font script="Bugi" typeface="Leelawadee UI"/>
+        <a:font script="Bopo" typeface="Microsoft JhengHei"/>
+        <a:font script="Java" typeface="Javanese Text"/>
+        <a:font script="Lisu" typeface="Segoe UI"/>
+        <a:font script="Mymr" typeface="Myanmar Text"/>
+        <a:font script="Nkoo" typeface="Ebrima"/>
+        <a:font script="Olck" typeface="Nirmala UI"/>
+        <a:font script="Osma" typeface="Ebrima"/>
+        <a:font script="Phag" typeface="Phagspa"/>
+        <a:font script="Syrn" typeface="Estrangelo Edessa"/>
+        <a:font script="Syrj" typeface="Estrangelo Edessa"/>
+        <a:font script="Syre" typeface="Estrangelo Edessa"/>
+        <a:font script="Sora" typeface="Nirmala UI"/>
+        <a:font script="Tale" typeface="Microsoft Tai Le"/>
+        <a:font script="Talu" typeface="Microsoft New Tai Lue"/>
+        <a:font script="Tfng" typeface="Ebrima"/>
+      </a:minorFont>
+    </a:fontScheme>
+    <a:fmtScheme name="Office">
+      <a:fillStyleLst>
+        <a:solidFill>
+          <a:schemeClr val="phClr"/>
+        </a:solidFill>
+        <a:gradFill rotWithShape="1">
+          <a:gsLst>
+            <a:gs pos="0">
+              <a:schemeClr val="phClr">
+                <a:lumMod val="110000"/>
+                <a:satMod val="105000"/>
+                <a:tint val="67000"/>
+              </a:schemeClr>
+            </a:gs>
+            <a:gs pos="50000">
+              <a:schemeClr val="phClr">
+                <a:lumMod val="105000"/>
+                <a:satMod val="103000"/>
+                <a:tint val="73000"/>
+              </a:schemeClr>
+            </a:gs>
+            <a:gs pos="100000">
+              <a:schemeClr val="phClr">
+                <a:lumMod val="105000"/>
+                <a:satMod val="109000"/>
+                <a:tint val="81000"/>
+              </a:schemeClr>
+            </a:gs>
+          </a:gsLst>
+          <a:lin ang="5400000" scaled="0"/>
+        </a:gradFill>
+        <a:gradFill rotWithShape="1">
+          <a:gsLst>
+            <a:gs pos="0">
+              <a:schemeClr val="phClr">
+                <a:satMod val="103000"/>
+                <a:lumMod val="102000"/>
+                <a:tint val="94000"/>
+              </a:schemeClr>
+            </a:gs>
+            <a:gs pos="50000">
+              <a:schemeClr val="phClr">
+                <a:satMod val="110000"/>
+                <a:lumMod val="100000"/>
+                <a:shade val="100000"/>
+              </a:schemeClr>
+            </a:gs>
+            <a:gs pos="100000">
+              <a:schemeClr val="phClr">
+                <a:lumMod val="99000"/>
+                <a:satMod val="120000"/>
+                <a:shade val="78000"/>
+              </a:schemeClr>
+            </a:gs>
+          </a:gsLst>
+          <a:lin ang="5400000" scaled="0"/>
+        </a:gradFill>
+      </a:fillStyleLst>
+      <a:lnStyleLst>
+        <a:ln w="12700" cap="flat" cmpd="sng" algn="ctr">
+          <a:solidFill>
+            <a:schemeClr val="phClr"/>
+          </a:solidFill>
+          <a:prstDash val="solid"/>
+          <a:miter lim="800000"/>
+        </a:ln>
+        <a:ln w="19050" cap="flat" cmpd="sng" algn="ctr">
+          <a:solidFill>
+            <a:schemeClr val="phClr"/>
+          </a:solidFill>
+          <a:prstDash val="solid"/>
+          <a:miter lim="800000"/>
+        </a:ln>
+        <a:ln w="25400" cap="flat" cmpd="sng" algn="ctr">
+          <a:solidFill>
+            <a:schemeClr val="phClr"/>
+          </a:solidFill>
+          <a:prstDash val="solid"/>
+          <a:miter lim="800000"/>
+        </a:ln>
+      </a:lnStyleLst>
+      <a:effectStyleLst>
+        <a:effectStyle>
+          <a:effectLst/>
+        </a:effectStyle>
+        <a:effectStyle>
+          <a:effectLst/>
+        </a:effectStyle>
+        <a:effectStyle>
+          <a:effectLst>
+            <a:outerShdw blurRad="57150" dist="19050" dir="5400000" algn="ctr" rotWithShape="0">
+              <a:srgbClr val="000000">
+                <a:alpha val="63000"/>
+              </a:srgbClr>
+            </a:outerShdw>
+          </a:effectLst>
+        </a:effectStyle>
+      </a:effectStyleLst>
+      <a:bgFillStyleLst>
+        <a:solidFill>
+          <a:schemeClr val="phClr"/>
+        </a:solidFill>
+        <a:solidFill>
+          <a:schemeClr val="phClr">
+            <a:tint val="95000"/>
+            <a:satMod val="170000"/>
+          </a:schemeClr>
+        </a:solidFill>
+        <a:gradFill rotWithShape="1">
+          <a:gsLst>
+            <a:gs pos="0">
+              <a:schemeClr val="phClr">
+                <a:tint val="93000"/>
+                <a:satMod val="150000"/>
+                <a:shade val="98000"/>
+                <a:lumMod val="102000"/>
+              </a:schemeClr>
+            </a:gs>
+            <a:gs pos="50000">
+              <a:schemeClr val="phClr">
+                <a:tint val="98000"/>
+                <a:satMod val="130000"/>
+                <a:shade val="90000"/>
+                <a:lumMod val="103000"/>
+              </a:schemeClr>
+            </a:gs>
+            <a:gs pos="100000">
+              <a:schemeClr val="phClr">
+                <a:shade val="63000"/>
+                <a:satMod val="120000"/>
+              </a:schemeClr>
+            </a:gs>
+          </a:gsLst>
+          <a:lin ang="5400000" scaled="0"/>
+        </a:gradFill>
+      </a:bgFillStyleLst>
+    </a:fmtScheme>
+  </a:themeElements>
+  <a:objectDefaults>
+    <a:lnDef>
+      <a:spPr/>
+      <a:bodyPr/>
+      <a:lstStyle/>
+      <a:style>
+        <a:lnRef idx="2">
+          <a:schemeClr val="accent1"/>
+        </a:lnRef>
+        <a:fillRef idx="0">
+          <a:schemeClr val="accent1"/>
+        </a:fillRef>
+        <a:effectRef idx="1">
+          <a:schemeClr val="accent1"/>
+        </a:effectRef>
+        <a:fontRef idx="minor">
+          <a:schemeClr val="tx1"/>
+        </a:fontRef>
+      </a:style>
+    </a:lnDef>
+  </a:objectDefaults>
+  <a:extraClrSchemeLst/>
+  <a:extLst>
+    <a:ext uri="{05A4C25C-085E-4340-85A3-A5531E510DB2}">
+      <thm15:themeFamily xmlns:thm15="http://schemas.microsoft.com/office/thememl/2012/main" name="Office Theme" id="{2E142A2C-CD16-42D6-873A-C26D2A0506FA}" vid="{1BDDFF52-6CD6-40A5-AB3C-68EB2F1E4D0A}"/>
+    </a:ext>
+  </a:extLst>
+</a:theme>
 </file>
</xml_diff>